<commit_message>
L8: blocchi e rientro nella dispensa completa e nelle slide complete
Co-Authored-By: Claude Opus 5.5 <noreply@anthropic.com>
Claude-Session: https://claude.ai/code/session_014CzWDFXvYNxqLeD99LSN3G
</commit_message>
<xml_diff>
--- a/L08_funzioni_cicli/slide_complete.pptx
+++ b/L08_funzioni_cicli/slide_complete.pptx
@@ -17,9 +17,10 @@
     <p:sldId id="265" r:id="rId11"/>
     <p:sldId id="266" r:id="rId12"/>
     <p:sldId id="267" r:id="rId13"/>
+    <p:sldId id="268" r:id="rId14"/>
   </p:sldIdLst>
   <p:notesMasterIdLst>
-    <p:notesMasterId r:id="rId14"/>
+    <p:notesMasterId r:id="rId15"/>
   </p:notesMasterIdLst>
   <p:sldSz cx="12192000" cy="6858000"/>
   <p:notesSz cx="6858000" cy="12192000"/>
@@ -118,36 +119,37 @@
   <p:extLst>
     <p:ext uri="{521415D9-36F7-43E2-AB2F-B90AF26B5E84}">
       <p14:sectionLst xmlns:p14="http://schemas.microsoft.com/office/powerpoint/2010/main">
-        <p14:section name="Apertura" id="{8a168ac5-4755-e5bc-4237-05d19057bbea}">
+        <p14:section name="Apertura" id="{a29e8e35-bef3-e0e1-9c13-4b167b28c3b9}">
           <p14:sldIdLst>
             <p14:sldId id="256"/>
             <p14:sldId id="257"/>
           </p14:sldIdLst>
         </p14:section>
-        <p14:section name="Spiegazione" id="{a3d95a88-02d5-877c-54ce-a24d618003b9}">
+        <p14:section name="Spiegazione" id="{8a6e007e-599f-8bba-c1b9-dbed959c47ab}">
           <p14:sldIdLst>
             <p14:sldId id="258"/>
             <p14:sldId id="259"/>
             <p14:sldId id="260"/>
             <p14:sldId id="261"/>
             <p14:sldId id="262"/>
-          </p14:sldIdLst>
-        </p14:section>
-        <p14:section name="Task" id="{c72c0bcb-d72e-cbb1-81fa-04fcaad61580}">
-          <p14:sldIdLst>
             <p14:sldId id="263"/>
           </p14:sldIdLst>
         </p14:section>
-        <p14:section name="Debrief" id="{fec4b7c1-b93b-1a5b-c0fe-b873ddc2ae97}">
+        <p14:section name="Task" id="{d8a543ea-6d49-780c-2db2-9754f1a41dfb}">
           <p14:sldIdLst>
             <p14:sldId id="264"/>
+          </p14:sldIdLst>
+        </p14:section>
+        <p14:section name="Debrief" id="{59c55da1-2af9-da8e-4f83-812bdd6a62dd}">
+          <p14:sldIdLst>
             <p14:sldId id="265"/>
             <p14:sldId id="266"/>
+            <p14:sldId id="267"/>
           </p14:sldIdLst>
         </p14:section>
-        <p14:section name="Chiusura" id="{ae3c8615-df06-afe6-7ccd-a91cd3754317}">
+        <p14:section name="Chiusura" id="{7426c57e-fafd-304f-5b31-d98d329f3758}">
           <p14:sldIdLst>
-            <p14:sldId id="267"/>
+            <p14:sldId id="268"/>
           </p14:sldIdLst>
         </p14:section>
       </p14:sectionLst>
@@ -642,7 +644,7 @@
           <a:p>
             <a:r>
               <a:rPr lang="en-US" dirty="0"/>
-              <a:t>Collegare alla L1: gli errori sono amici. Qui l'errore ha evitato un riepilogo con 19 regioni su 20. Nel bonus B2, senza la correzione, concat avrebbe creato due colonne diverse.</a:t>
+              <a:t/>
             </a:r>
             <a:endParaRPr lang="en-US" dirty="0"/>
           </a:p>
@@ -730,7 +732,7 @@
           <a:p>
             <a:r>
               <a:rPr lang="en-US" dirty="0"/>
-              <a:t/>
+              <a:t>Collegare alla L1: gli errori sono amici. Qui l'errore ha evitato un riepilogo con 19 regioni su 20. Nel bonus B2, senza la correzione, concat avrebbe creato due colonne diverse.</a:t>
             </a:r>
             <a:endParaRPr lang="en-US" dirty="0"/>
           </a:p>
@@ -860,6 +862,94 @@
 </p:notes>
 </file>
 
+<file path=ppt/notesSlides/notesSlide13.xml><?xml version="1.0" encoding="utf-8"?>
+<p:notes xmlns:a="http://schemas.openxmlformats.org/drawingml/2006/main" xmlns:r="http://schemas.openxmlformats.org/officeDocument/2006/relationships" xmlns:p="http://schemas.openxmlformats.org/presentationml/2006/main">
+  <p:cSld>
+    <p:spTree>
+      <p:nvGrpSpPr>
+        <p:cNvPr id="1" name=""/>
+        <p:cNvGrpSpPr/>
+        <p:nvPr/>
+      </p:nvGrpSpPr>
+      <p:grpSpPr>
+        <a:xfrm>
+          <a:off x="0" y="0"/>
+          <a:ext cx="0" cy="0"/>
+          <a:chOff x="0" y="0"/>
+          <a:chExt cx="0" cy="0"/>
+        </a:xfrm>
+      </p:grpSpPr>
+      <p:sp>
+        <p:nvSpPr>
+          <p:cNvPr id="2" name="Slide Image Placeholder 1"/>
+          <p:cNvSpPr>
+            <a:spLocks noGrp="1" noRot="1" noChangeAspect="1"/>
+          </p:cNvSpPr>
+          <p:nvPr>
+            <p:ph type="sldImg"/>
+          </p:nvPr>
+        </p:nvSpPr>
+        <p:spPr/>
+      </p:sp>
+      <p:sp>
+        <p:nvSpPr>
+          <p:cNvPr id="3" name="Notes Placeholder 2"/>
+          <p:cNvSpPr>
+            <a:spLocks noGrp="1"/>
+          </p:cNvSpPr>
+          <p:nvPr>
+            <p:ph type="body" idx="1"/>
+          </p:nvPr>
+        </p:nvSpPr>
+        <p:spPr/>
+        <p:txBody>
+          <a:bodyPr/>
+          <a:lstStyle/>
+          <a:p>
+            <a:r>
+              <a:rPr lang="en-US" dirty="0"/>
+              <a:t/>
+            </a:r>
+            <a:endParaRPr lang="en-US" dirty="0"/>
+          </a:p>
+        </p:txBody>
+      </p:sp>
+      <p:sp>
+        <p:nvSpPr>
+          <p:cNvPr id="4" name="Slide Number Placeholder 3"/>
+          <p:cNvSpPr>
+            <a:spLocks noGrp="1"/>
+          </p:cNvSpPr>
+          <p:nvPr>
+            <p:ph type="sldNum" sz="quarter" idx="10"/>
+          </p:nvPr>
+        </p:nvSpPr>
+        <p:spPr/>
+        <p:txBody>
+          <a:bodyPr/>
+          <a:lstStyle/>
+          <a:p>
+            <a:fld id="{F7021451-1387-4CA6-816F-3879F97B5CBC}" type="slidenum">
+              <a:rPr lang="en-US"/>
+              <a:t>13</a:t>
+            </a:fld>
+            <a:endParaRPr lang="en-US"/>
+          </a:p>
+        </p:txBody>
+      </p:sp>
+    </p:spTree>
+    <p:extLst>
+      <p:ext uri="{BB962C8B-B14F-4D97-AF65-F5344CB8AC3E}">
+        <p14:creationId xmlns:p14="http://schemas.microsoft.com/office/powerpoint/2010/main" val="1024086991"/>
+      </p:ext>
+    </p:extLst>
+  </p:cSld>
+  <p:clrMapOvr>
+    <a:masterClrMapping/>
+  </p:clrMapOvr>
+</p:notes>
+</file>
+
 <file path=ppt/notesSlides/notesSlide2.xml><?xml version="1.0" encoding="utf-8"?>
 <p:notes xmlns:a="http://schemas.openxmlformats.org/drawingml/2006/main" xmlns:r="http://schemas.openxmlformats.org/officeDocument/2006/relationships" xmlns:p="http://schemas.openxmlformats.org/presentationml/2006/main">
   <p:cSld>
@@ -1258,7 +1348,7 @@
           <a:p>
             <a:r>
               <a:rPr lang="en-US" dirty="0"/>
-              <a:t>Mostrare il pannello dei file di Colab dopo il git clone. Path è il modo moderno di gestire i percorsi in Python.</a:t>
+              <a:t>DEMO: togliere il rientro a print(f.stem, ...) e far vedere l'IndentationError; poi spostare print("fatto") dentro il ciclo e far notare che viene stampato a ogni giro. Funzioni, cicli e if seguono tutti la stessa regola.</a:t>
             </a:r>
             <a:endParaRPr lang="en-US" dirty="0"/>
           </a:p>
@@ -1346,7 +1436,7 @@
           <a:p>
             <a:r>
               <a:rPr lang="en-US" dirty="0"/>
-              <a:t>Non anticipare quale file darà problemi.</a:t>
+              <a:t>Mostrare il pannello dei file di Colab dopo il git clone. Path è il modo moderno di gestire i percorsi in Python.</a:t>
             </a:r>
             <a:endParaRPr lang="en-US" dirty="0"/>
           </a:p>
@@ -1434,7 +1524,7 @@
           <a:p>
             <a:r>
               <a:rPr lang="en-US" dirty="0"/>
-              <a:t>Al passo 6 il ciclo si ferma: è voluto. Aiutare a leggere l'errore, non a risolverlo.</a:t>
+              <a:t>Non anticipare quale file darà problemi.</a:t>
             </a:r>
             <a:endParaRPr lang="en-US" dirty="0"/>
           </a:p>
@@ -1522,7 +1612,7 @@
           <a:p>
             <a:r>
               <a:rPr lang="en-US" dirty="0"/>
-              <a:t/>
+              <a:t>Al passo 6 il ciclo si ferma: è voluto. Aiutare a leggere l'errore, non a risolverlo.</a:t>
             </a:r>
             <a:endParaRPr lang="en-US" dirty="0"/>
           </a:p>
@@ -2419,102 +2509,46 @@
         </p:nvSpPr>
         <p:spPr>
           <a:xfrm>
-            <a:off x="548640" y="365760"/>
-            <a:ext cx="11064240" cy="822960"/>
-          </a:xfrm>
-          <a:prstGeom prst="rect">
-            <a:avLst/>
-          </a:prstGeom>
-          <a:noFill/>
-          <a:ln/>
-        </p:spPr>
-        <p:txBody>
-          <a:bodyPr wrap="square" lIns="0" tIns="0" rIns="0" bIns="0" rtlCol="0" anchor="ctr"/>
+            <a:off x="731520" y="2194560"/>
+            <a:ext cx="10698480" cy="1280160"/>
+          </a:xfrm>
+          <a:prstGeom prst="rect">
+            <a:avLst/>
+          </a:prstGeom>
+          <a:noFill/>
+          <a:ln/>
+        </p:spPr>
+        <p:txBody>
+          <a:bodyPr wrap="square" lIns="0" tIns="0" rIns="0" bIns="0" rtlCol="0" anchor="b"/>
           <a:lstStyle/>
           <a:p>
             <a:pPr algn="l" indent="0" marL="0">
               <a:buNone/>
             </a:pPr>
             <a:r>
-              <a:rPr lang="en-US" sz="3600" b="1" dirty="0">
-                <a:solidFill>
-                  <a:srgbClr val="0F4C5C"/>
-                </a:solidFill>
-              </a:rPr>
-              <a:t>Il Molise</a:t>
-            </a:r>
-            <a:endParaRPr lang="en-US" sz="3600" dirty="0"/>
-          </a:p>
-        </p:txBody>
-      </p:sp>
-      <p:sp>
-        <p:nvSpPr>
-          <p:cNvPr id="3" name="card-err"/>
+              <a:rPr lang="en-US" sz="5400" b="1" dirty="0">
+                <a:solidFill>
+                  <a:srgbClr val="FFFFFF"/>
+                </a:solidFill>
+              </a:rPr>
+              <a:t>Debrief</a:t>
+            </a:r>
+            <a:endParaRPr lang="en-US" sz="5400" dirty="0"/>
+          </a:p>
+        </p:txBody>
+      </p:sp>
+      <p:sp>
+        <p:nvSpPr>
+          <p:cNvPr id="3" name="Text 0"/>
           <p:cNvSpPr/>
-          <p:nvPr/>
-        </p:nvSpPr>
-        <p:spPr>
-          <a:xfrm>
-            <a:off x="548640" y="1737360"/>
-            <a:ext cx="6035040" cy="1188720"/>
-          </a:xfrm>
-          <a:prstGeom prst="roundRect">
-            <a:avLst>
-              <a:gd name="adj" fmla="val 9231"/>
-            </a:avLst>
-          </a:prstGeom>
-          <a:solidFill>
-            <a:srgbClr val="FBEAEA"/>
-          </a:solidFill>
-          <a:ln/>
-        </p:spPr>
-      </p:sp>
-      <p:sp>
-        <p:nvSpPr>
-          <p:cNvPr id="4" name="Text 2"/>
-          <p:cNvSpPr txBox="1"/>
-          <p:nvPr/>
-        </p:nvSpPr>
-        <p:spPr>
-          <a:xfrm>
-            <a:off x="777240" y="1874520"/>
-            <a:ext cx="1828800" cy="274320"/>
-          </a:xfrm>
-          <a:prstGeom prst="rect">
-            <a:avLst/>
-          </a:prstGeom>
-          <a:noFill/>
-          <a:ln/>
-        </p:spPr>
-        <p:txBody>
-          <a:bodyPr wrap="square" lIns="0" tIns="0" rIns="0" bIns="0" rtlCol="0" anchor="ctr"/>
-          <a:lstStyle/>
-          <a:p>
-            <a:pPr indent="0" marL="0">
-              <a:buNone/>
-            </a:pPr>
-            <a:r>
-              <a:rPr lang="en-US" sz="1100" b="1" spc="200" kern="0" dirty="0">
-                <a:solidFill>
-                  <a:srgbClr val="9E2A2B"/>
-                </a:solidFill>
-              </a:rPr>
-              <a:t>ERRORE</a:t>
-            </a:r>
-            <a:endParaRPr lang="en-US" sz="1100" dirty="0"/>
-          </a:p>
-        </p:txBody>
-      </p:sp>
-      <p:sp>
-        <p:nvSpPr>
-          <p:cNvPr id="5" name="Text 3"/>
-          <p:cNvSpPr txBox="1"/>
-          <p:nvPr/>
-        </p:nvSpPr>
-        <p:spPr>
-          <a:xfrm>
-            <a:off x="777240" y="2194560"/>
-            <a:ext cx="5577840" cy="594360"/>
+          <p:nvPr>
+            <p:ph idx="101" type="body" hasCustomPrompt="1"/>
+          </p:nvPr>
+        </p:nvSpPr>
+        <p:spPr>
+          <a:xfrm>
+            <a:off x="731520" y="3657600"/>
+            <a:ext cx="10698480" cy="1463040"/>
           </a:xfrm>
           <a:prstGeom prst="rect">
             <a:avLst/>
@@ -2530,232 +2564,14 @@
               <a:buNone/>
             </a:pPr>
             <a:r>
-              <a:rPr lang="en-US" sz="2000" dirty="0">
-                <a:solidFill>
-                  <a:srgbClr val="9E2A2B"/>
-                </a:solidFill>
-                <a:latin typeface="Courier New" pitchFamily="34" charset="0"/>
-                <a:ea typeface="Courier New" pitchFamily="34" charset="-122"/>
-                <a:cs typeface="Courier New" pitchFamily="34" charset="-120"/>
-              </a:rPr>
-              <a:t>KeyError: 'fatturato'</a:t>
-            </a:r>
-            <a:endParaRPr lang="en-US" sz="2000" dirty="0"/>
-          </a:p>
-        </p:txBody>
-      </p:sp>
-      <p:sp>
-        <p:nvSpPr>
-          <p:cNvPr id="6" name="card-code"/>
-          <p:cNvSpPr/>
-          <p:nvPr/>
-        </p:nvSpPr>
-        <p:spPr>
-          <a:xfrm>
-            <a:off x="548640" y="3154680"/>
-            <a:ext cx="6035040" cy="1188720"/>
-          </a:xfrm>
-          <a:prstGeom prst="roundRect">
-            <a:avLst>
-              <a:gd name="adj" fmla="val 9231"/>
-            </a:avLst>
-          </a:prstGeom>
-          <a:solidFill>
-            <a:srgbClr val="1F2A30"/>
-          </a:solidFill>
-          <a:ln/>
-        </p:spPr>
-      </p:sp>
-      <p:sp>
-        <p:nvSpPr>
-          <p:cNvPr id="7" name="Text 5"/>
-          <p:cNvSpPr txBox="1"/>
-          <p:nvPr/>
-        </p:nvSpPr>
-        <p:spPr>
-          <a:xfrm>
-            <a:off x="777240" y="3291840"/>
-            <a:ext cx="1828800" cy="274320"/>
-          </a:xfrm>
-          <a:prstGeom prst="rect">
-            <a:avLst/>
-          </a:prstGeom>
-          <a:noFill/>
-          <a:ln/>
-        </p:spPr>
-        <p:txBody>
-          <a:bodyPr wrap="square" lIns="0" tIns="0" rIns="0" bIns="0" rtlCol="0" anchor="ctr"/>
-          <a:lstStyle/>
-          <a:p>
-            <a:pPr indent="0" marL="0">
-              <a:buNone/>
-            </a:pPr>
-            <a:r>
-              <a:rPr lang="en-US" sz="1100" b="1" spc="200" kern="0" dirty="0">
-                <a:solidFill>
-                  <a:srgbClr val="E09F3E"/>
-                </a:solidFill>
-              </a:rPr>
-              <a:t>PYTHON</a:t>
-            </a:r>
-            <a:endParaRPr lang="en-US" sz="1100" dirty="0"/>
-          </a:p>
-        </p:txBody>
-      </p:sp>
-      <p:sp>
-        <p:nvSpPr>
-          <p:cNvPr id="8" name="Text 6"/>
-          <p:cNvSpPr txBox="1"/>
-          <p:nvPr/>
-        </p:nvSpPr>
-        <p:spPr>
-          <a:xfrm>
-            <a:off x="777240" y="3611880"/>
-            <a:ext cx="5577840" cy="594360"/>
-          </a:xfrm>
-          <a:prstGeom prst="rect">
-            <a:avLst/>
-          </a:prstGeom>
-          <a:noFill/>
-          <a:ln/>
-        </p:spPr>
-        <p:txBody>
-          <a:bodyPr wrap="square" lIns="0" tIns="0" rIns="0" bIns="0" rtlCol="0" anchor="t"/>
-          <a:lstStyle/>
-          <a:p>
-            <a:pPr indent="0" marL="0">
-              <a:buNone/>
-            </a:pPr>
-            <a:r>
-              <a:rPr lang="en-US" sz="1800" dirty="0">
-                <a:solidFill>
-                  <a:srgbClr val="FFFFFF"/>
-                </a:solidFill>
-                <a:latin typeface="Courier New" pitchFamily="34" charset="0"/>
-                <a:ea typeface="Courier New" pitchFamily="34" charset="-122"/>
-                <a:cs typeface="Courier New" pitchFamily="34" charset="-120"/>
-              </a:rPr>
-              <a:t>df.columns = df.columns.str.lower()</a:t>
-            </a:r>
-            <a:endParaRPr lang="en-US" sz="1800" dirty="0"/>
-          </a:p>
-        </p:txBody>
-      </p:sp>
-      <p:sp>
-        <p:nvSpPr>
-          <p:cNvPr id="9" name="Text 7"/>
-          <p:cNvSpPr txBox="1"/>
-          <p:nvPr/>
-        </p:nvSpPr>
-        <p:spPr>
-          <a:xfrm>
-            <a:off x="6949440" y="1828800"/>
-            <a:ext cx="4663440" cy="3840480"/>
-          </a:xfrm>
-          <a:prstGeom prst="rect">
-            <a:avLst/>
-          </a:prstGeom>
-          <a:noFill/>
-          <a:ln/>
-        </p:spPr>
-        <p:txBody>
-          <a:bodyPr wrap="square" lIns="0" tIns="0" rIns="0" bIns="0" rtlCol="0" anchor="t"/>
-          <a:lstStyle/>
-          <a:p>
-            <a:pPr indent="0" marL="0">
-              <a:spcAft>
-                <a:spcPts val="1000"/>
-              </a:spcAft>
-              <a:buNone/>
-            </a:pPr>
-            <a:r>
-              <a:rPr lang="en-US" sz="1800" dirty="0">
-                <a:solidFill>
-                  <a:srgbClr val="1F2A30"/>
-                </a:solidFill>
-              </a:rPr>
-              <a:t>In Molise.xlsx la colonna si chiamava «Fatturato», con la maiuscola.</a:t>
-            </a:r>
-            <a:endParaRPr lang="en-US" sz="1800" dirty="0"/>
-          </a:p>
-          <a:p>
-            <a:pPr indent="0" marL="0">
-              <a:spcAft>
-                <a:spcPts val="1000"/>
-              </a:spcAft>
-              <a:buNone/>
-            </a:pPr>
-            <a:r>
-              <a:rPr lang="en-US" sz="1800" dirty="0">
-                <a:solidFill>
-                  <a:srgbClr val="1F2A30"/>
-                </a:solidFill>
-              </a:rPr>
-              <a:t>In Excel non ce ne saremmo accorti: avremmo cliccato sulla colonna giusta.</a:t>
-            </a:r>
-            <a:endParaRPr lang="en-US" sz="1800" dirty="0"/>
-          </a:p>
-          <a:p>
-            <a:pPr indent="0" marL="0">
-              <a:spcAft>
-                <a:spcPts val="1000"/>
-              </a:spcAft>
-              <a:buNone/>
-            </a:pPr>
-            <a:r>
-              <a:rPr lang="en-US" sz="1800" b="1" dirty="0">
-                <a:solidFill>
-                  <a:srgbClr val="0F4C5C"/>
-                </a:solidFill>
-              </a:rPr>
-              <a:t>Il codice si è fermato, e ce l'ha detto. Meglio un errore che un risultato sbagliato.</a:t>
-            </a:r>
-            <a:endParaRPr lang="en-US" sz="1800" dirty="0"/>
-          </a:p>
-        </p:txBody>
-      </p:sp>
-      <p:sp>
-        <p:nvSpPr>
-          <p:cNvPr id="25" name="Slide Number Placeholder 0"/>
-          <p:cNvSpPr>
-            <a:spLocks noGrp="1"/>
-          </p:cNvSpPr>
-          <p:nvPr>
-            <p:ph type="sldNum" sz="quarter" idx="4294967295"/>
-          </p:nvPr>
-        </p:nvSpPr>
-        <p:spPr>
-          <a:xfrm>
-            <a:off x="11155680" y="6400800"/>
-            <a:ext cx="457200" cy="274320"/>
-          </a:xfrm>
-          <a:prstGeom prst="rect">
-            <a:avLst/>
-          </a:prstGeom>
-          <a:extLst>
-            <a:ext uri="{C572A759-6A51-4108-AA02-DFA0A04FC94B}">
-              <ma14:wrappingTextBoxFlag xmlns:ma14="http://schemas.microsoft.com/office/mac/drawingml/2011/main" val="0"/>
-            </a:ext>
-          </a:extLst>
-        </p:spPr>
-        <p:txBody>
-          <a:bodyPr/>
-          <a:lstStyle>
-            <a:lvl1pPr>
-              <a:defRPr sz="1000">
-                <a:solidFill>
-                  <a:srgbClr val="5C6F7B"/>
-                </a:solidFill>
-              </a:defRPr>
-            </a:lvl1pPr>
-          </a:lstStyle>
-          <a:p>
-            <a:pPr algn="r"/>
-            <a:fld id="{F7021451-1387-4CA6-816F-3879F97B5CBC}" type="slidenum">
-              <a:rPr b="0" lang="en-US"/>
-              <a:t>10</a:t>
-            </a:fld>
-            <a:endParaRPr lang="en-US"/>
+              <a:rPr lang="en-US" sz="2200" dirty="0">
+                <a:solidFill>
+                  <a:srgbClr val="B8C4CB"/>
+                </a:solidFill>
+              </a:rPr>
+              <a:t>Il file diverso dagli altri</a:t>
+            </a:r>
+            <a:endParaRPr lang="en-US" sz="2200" dirty="0"/>
           </a:p>
         </p:txBody>
       </p:sp>
@@ -2816,7 +2632,7 @@
                   <a:srgbClr val="0F4C5C"/>
                 </a:solidFill>
               </a:rPr>
-              <a:t>Cosa abbiamo guadagnato</a:t>
+              <a:t>Il Molise</a:t>
             </a:r>
             <a:endParaRPr lang="en-US" sz="3600" dirty="0"/>
           </a:p>
@@ -2824,218 +2640,133 @@
       </p:sp>
       <p:sp>
         <p:nvSpPr>
-          <p:cNvPr id="3" name="Shape 1"/>
+          <p:cNvPr id="3" name="card-err"/>
           <p:cNvSpPr/>
           <p:nvPr/>
         </p:nvSpPr>
         <p:spPr>
           <a:xfrm>
             <a:off x="548640" y="1737360"/>
-            <a:ext cx="3505200" cy="2926080"/>
+            <a:ext cx="6035040" cy="1188720"/>
           </a:xfrm>
           <a:prstGeom prst="roundRect">
             <a:avLst>
-              <a:gd name="adj" fmla="val 3750"/>
+              <a:gd name="adj" fmla="val 9231"/>
             </a:avLst>
           </a:prstGeom>
           <a:solidFill>
-            <a:srgbClr val="EEF3F4"/>
+            <a:srgbClr val="FBEAEA"/>
           </a:solidFill>
           <a:ln/>
         </p:spPr>
       </p:sp>
       <p:sp>
         <p:nvSpPr>
-          <p:cNvPr id="4" name="Shape 2"/>
+          <p:cNvPr id="4" name="Text 2"/>
+          <p:cNvSpPr txBox="1"/>
+          <p:nvPr/>
+        </p:nvSpPr>
+        <p:spPr>
+          <a:xfrm>
+            <a:off x="777240" y="1874520"/>
+            <a:ext cx="1828800" cy="274320"/>
+          </a:xfrm>
+          <a:prstGeom prst="rect">
+            <a:avLst/>
+          </a:prstGeom>
+          <a:noFill/>
+          <a:ln/>
+        </p:spPr>
+        <p:txBody>
+          <a:bodyPr wrap="square" lIns="0" tIns="0" rIns="0" bIns="0" rtlCol="0" anchor="ctr"/>
+          <a:lstStyle/>
+          <a:p>
+            <a:pPr indent="0" marL="0">
+              <a:buNone/>
+            </a:pPr>
+            <a:r>
+              <a:rPr lang="en-US" sz="1100" b="1" spc="200" kern="0" dirty="0">
+                <a:solidFill>
+                  <a:srgbClr val="9E2A2B"/>
+                </a:solidFill>
+              </a:rPr>
+              <a:t>ERRORE</a:t>
+            </a:r>
+            <a:endParaRPr lang="en-US" sz="1100" dirty="0"/>
+          </a:p>
+        </p:txBody>
+      </p:sp>
+      <p:sp>
+        <p:nvSpPr>
+          <p:cNvPr id="5" name="Text 3"/>
+          <p:cNvSpPr txBox="1"/>
+          <p:nvPr/>
+        </p:nvSpPr>
+        <p:spPr>
+          <a:xfrm>
+            <a:off x="777240" y="2194560"/>
+            <a:ext cx="5577840" cy="594360"/>
+          </a:xfrm>
+          <a:prstGeom prst="rect">
+            <a:avLst/>
+          </a:prstGeom>
+          <a:noFill/>
+          <a:ln/>
+        </p:spPr>
+        <p:txBody>
+          <a:bodyPr wrap="square" lIns="0" tIns="0" rIns="0" bIns="0" rtlCol="0" anchor="t"/>
+          <a:lstStyle/>
+          <a:p>
+            <a:pPr indent="0" marL="0">
+              <a:buNone/>
+            </a:pPr>
+            <a:r>
+              <a:rPr lang="en-US" sz="2000" dirty="0">
+                <a:solidFill>
+                  <a:srgbClr val="9E2A2B"/>
+                </a:solidFill>
+                <a:latin typeface="Courier New" pitchFamily="34" charset="0"/>
+                <a:ea typeface="Courier New" pitchFamily="34" charset="-122"/>
+                <a:cs typeface="Courier New" pitchFamily="34" charset="-120"/>
+              </a:rPr>
+              <a:t>KeyError: 'fatturato'</a:t>
+            </a:r>
+            <a:endParaRPr lang="en-US" sz="2000" dirty="0"/>
+          </a:p>
+        </p:txBody>
+      </p:sp>
+      <p:sp>
+        <p:nvSpPr>
+          <p:cNvPr id="6" name="card-code"/>
           <p:cNvSpPr/>
           <p:nvPr/>
         </p:nvSpPr>
         <p:spPr>
           <a:xfrm>
-            <a:off x="822960" y="2011680"/>
-            <a:ext cx="914400" cy="914400"/>
-          </a:xfrm>
-          <a:prstGeom prst="ellipse">
-            <a:avLst/>
-          </a:prstGeom>
-          <a:solidFill>
-            <a:srgbClr val="FFFFFF"/>
-          </a:solidFill>
-          <a:ln/>
-        </p:spPr>
-      </p:sp>
-      <p:pic>
-        <p:nvPicPr>
-          <p:cNvPr id="5" name="Image 0" descr="preencoded.png">    </p:cNvPr>
-          <p:cNvPicPr>
-            <a:picLocks noChangeAspect="1"/>
-          </p:cNvPicPr>
-          <p:nvPr/>
-        </p:nvPicPr>
-        <p:blipFill>
-          <a:blip r:embed="rId1"/>
-          <a:stretch>
-            <a:fillRect/>
-          </a:stretch>
-        </p:blipFill>
-        <p:spPr>
-          <a:xfrm>
-            <a:off x="1069848" y="2258568"/>
-            <a:ext cx="420624" cy="420624"/>
-          </a:xfrm>
-          <a:prstGeom prst="rect">
-            <a:avLst/>
-          </a:prstGeom>
-        </p:spPr>
-      </p:pic>
-      <p:sp>
-        <p:nvSpPr>
-          <p:cNvPr id="6" name="Text 3"/>
-          <p:cNvSpPr txBox="1"/>
-          <p:nvPr/>
-        </p:nvSpPr>
-        <p:spPr>
-          <a:xfrm>
-            <a:off x="822960" y="3154680"/>
-            <a:ext cx="2956560" cy="502920"/>
-          </a:xfrm>
-          <a:prstGeom prst="rect">
-            <a:avLst/>
-          </a:prstGeom>
-          <a:noFill/>
-          <a:ln/>
-        </p:spPr>
-        <p:txBody>
-          <a:bodyPr wrap="square" lIns="0" tIns="0" rIns="0" bIns="0" rtlCol="0" anchor="ctr"/>
-          <a:lstStyle/>
-          <a:p>
-            <a:pPr indent="0" marL="0">
-              <a:buNone/>
-            </a:pPr>
-            <a:r>
-              <a:rPr lang="en-US" sz="2200" b="1" dirty="0">
-                <a:solidFill>
-                  <a:srgbClr val="1F2A30"/>
-                </a:solidFill>
-              </a:rPr>
-              <a:t>Ripetibile</a:t>
-            </a:r>
-            <a:endParaRPr lang="en-US" sz="2200" dirty="0"/>
-          </a:p>
-        </p:txBody>
-      </p:sp>
-      <p:sp>
-        <p:nvSpPr>
-          <p:cNvPr id="7" name="Text 4"/>
-          <p:cNvSpPr txBox="1"/>
-          <p:nvPr/>
-        </p:nvSpPr>
-        <p:spPr>
-          <a:xfrm>
-            <a:off x="822960" y="3703320"/>
-            <a:ext cx="2956560" cy="777240"/>
-          </a:xfrm>
-          <a:prstGeom prst="rect">
-            <a:avLst/>
-          </a:prstGeom>
-          <a:noFill/>
-          <a:ln/>
-        </p:spPr>
-        <p:txBody>
-          <a:bodyPr wrap="square" lIns="0" tIns="0" rIns="0" bIns="0" rtlCol="0" anchor="t"/>
-          <a:lstStyle/>
-          <a:p>
-            <a:pPr indent="0" marL="0">
-              <a:buNone/>
-            </a:pPr>
-            <a:r>
-              <a:rPr lang="en-US" sz="1600" dirty="0">
-                <a:solidFill>
-                  <a:srgbClr val="5C6F7B"/>
-                </a:solidFill>
-              </a:rPr>
-              <a:t>domani arrivano i dati del 2024: rilanci tutto e hai il nuovo report.</a:t>
-            </a:r>
-            <a:endParaRPr lang="en-US" sz="1600" dirty="0"/>
-          </a:p>
-        </p:txBody>
-      </p:sp>
-      <p:sp>
-        <p:nvSpPr>
-          <p:cNvPr id="8" name="Shape 5"/>
-          <p:cNvSpPr/>
-          <p:nvPr/>
-        </p:nvSpPr>
-        <p:spPr>
-          <a:xfrm>
-            <a:off x="4328160" y="1737360"/>
-            <a:ext cx="3505200" cy="2926080"/>
+            <a:off x="548640" y="3154680"/>
+            <a:ext cx="6035040" cy="1188720"/>
           </a:xfrm>
           <a:prstGeom prst="roundRect">
             <a:avLst>
-              <a:gd name="adj" fmla="val 3750"/>
+              <a:gd name="adj" fmla="val 9231"/>
             </a:avLst>
           </a:prstGeom>
           <a:solidFill>
-            <a:srgbClr val="EEF3F4"/>
+            <a:srgbClr val="1F2A30"/>
           </a:solidFill>
           <a:ln/>
         </p:spPr>
       </p:sp>
       <p:sp>
         <p:nvSpPr>
-          <p:cNvPr id="9" name="Shape 6"/>
-          <p:cNvSpPr/>
-          <p:nvPr/>
-        </p:nvSpPr>
-        <p:spPr>
-          <a:xfrm>
-            <a:off x="4602480" y="2011680"/>
-            <a:ext cx="914400" cy="914400"/>
-          </a:xfrm>
-          <a:prstGeom prst="ellipse">
-            <a:avLst/>
-          </a:prstGeom>
-          <a:solidFill>
-            <a:srgbClr val="FFFFFF"/>
-          </a:solidFill>
-          <a:ln/>
-        </p:spPr>
-      </p:sp>
-      <p:pic>
-        <p:nvPicPr>
-          <p:cNvPr id="10" name="Image 1" descr="preencoded.png">    </p:cNvPr>
-          <p:cNvPicPr>
-            <a:picLocks noChangeAspect="1"/>
-          </p:cNvPicPr>
-          <p:nvPr/>
-        </p:nvPicPr>
-        <p:blipFill>
-          <a:blip r:embed="rId2"/>
-          <a:stretch>
-            <a:fillRect/>
-          </a:stretch>
-        </p:blipFill>
-        <p:spPr>
-          <a:xfrm>
-            <a:off x="4849368" y="2258568"/>
-            <a:ext cx="420624" cy="420624"/>
-          </a:xfrm>
-          <a:prstGeom prst="rect">
-            <a:avLst/>
-          </a:prstGeom>
-        </p:spPr>
-      </p:pic>
-      <p:sp>
-        <p:nvSpPr>
-          <p:cNvPr id="11" name="Text 7"/>
+          <p:cNvPr id="7" name="Text 5"/>
           <p:cNvSpPr txBox="1"/>
           <p:nvPr/>
         </p:nvSpPr>
         <p:spPr>
           <a:xfrm>
-            <a:off x="4602480" y="3154680"/>
-            <a:ext cx="2956560" cy="502920"/>
+            <a:off x="777240" y="3291840"/>
+            <a:ext cx="1828800" cy="274320"/>
           </a:xfrm>
           <a:prstGeom prst="rect">
             <a:avLst/>
@@ -3051,188 +2782,126 @@
               <a:buNone/>
             </a:pPr>
             <a:r>
-              <a:rPr lang="en-US" sz="2200" b="1" dirty="0">
+              <a:rPr lang="en-US" sz="1100" b="1" spc="200" kern="0" dirty="0">
+                <a:solidFill>
+                  <a:srgbClr val="E09F3E"/>
+                </a:solidFill>
+              </a:rPr>
+              <a:t>PYTHON</a:t>
+            </a:r>
+            <a:endParaRPr lang="en-US" sz="1100" dirty="0"/>
+          </a:p>
+        </p:txBody>
+      </p:sp>
+      <p:sp>
+        <p:nvSpPr>
+          <p:cNvPr id="8" name="Text 6"/>
+          <p:cNvSpPr txBox="1"/>
+          <p:nvPr/>
+        </p:nvSpPr>
+        <p:spPr>
+          <a:xfrm>
+            <a:off x="777240" y="3611880"/>
+            <a:ext cx="5577840" cy="594360"/>
+          </a:xfrm>
+          <a:prstGeom prst="rect">
+            <a:avLst/>
+          </a:prstGeom>
+          <a:noFill/>
+          <a:ln/>
+        </p:spPr>
+        <p:txBody>
+          <a:bodyPr wrap="square" lIns="0" tIns="0" rIns="0" bIns="0" rtlCol="0" anchor="t"/>
+          <a:lstStyle/>
+          <a:p>
+            <a:pPr indent="0" marL="0">
+              <a:buNone/>
+            </a:pPr>
+            <a:r>
+              <a:rPr lang="en-US" sz="1800" dirty="0">
+                <a:solidFill>
+                  <a:srgbClr val="FFFFFF"/>
+                </a:solidFill>
+                <a:latin typeface="Courier New" pitchFamily="34" charset="0"/>
+                <a:ea typeface="Courier New" pitchFamily="34" charset="-122"/>
+                <a:cs typeface="Courier New" pitchFamily="34" charset="-120"/>
+              </a:rPr>
+              <a:t>df.columns = df.columns.str.lower()</a:t>
+            </a:r>
+            <a:endParaRPr lang="en-US" sz="1800" dirty="0"/>
+          </a:p>
+        </p:txBody>
+      </p:sp>
+      <p:sp>
+        <p:nvSpPr>
+          <p:cNvPr id="9" name="Text 7"/>
+          <p:cNvSpPr txBox="1"/>
+          <p:nvPr/>
+        </p:nvSpPr>
+        <p:spPr>
+          <a:xfrm>
+            <a:off x="6949440" y="1828800"/>
+            <a:ext cx="4663440" cy="3840480"/>
+          </a:xfrm>
+          <a:prstGeom prst="rect">
+            <a:avLst/>
+          </a:prstGeom>
+          <a:noFill/>
+          <a:ln/>
+        </p:spPr>
+        <p:txBody>
+          <a:bodyPr wrap="square" lIns="0" tIns="0" rIns="0" bIns="0" rtlCol="0" anchor="t"/>
+          <a:lstStyle/>
+          <a:p>
+            <a:pPr indent="0" marL="0">
+              <a:spcAft>
+                <a:spcPts val="1000"/>
+              </a:spcAft>
+              <a:buNone/>
+            </a:pPr>
+            <a:r>
+              <a:rPr lang="en-US" sz="1800" dirty="0">
                 <a:solidFill>
                   <a:srgbClr val="1F2A30"/>
                 </a:solidFill>
               </a:rPr>
-              <a:t>Scalabile</a:t>
-            </a:r>
-            <a:endParaRPr lang="en-US" sz="2200" dirty="0"/>
-          </a:p>
-        </p:txBody>
-      </p:sp>
-      <p:sp>
-        <p:nvSpPr>
-          <p:cNvPr id="12" name="Text 8"/>
-          <p:cNvSpPr txBox="1"/>
-          <p:nvPr/>
-        </p:nvSpPr>
-        <p:spPr>
-          <a:xfrm>
-            <a:off x="4602480" y="3703320"/>
-            <a:ext cx="2956560" cy="777240"/>
-          </a:xfrm>
-          <a:prstGeom prst="rect">
-            <a:avLst/>
-          </a:prstGeom>
-          <a:noFill/>
-          <a:ln/>
-        </p:spPr>
-        <p:txBody>
-          <a:bodyPr wrap="square" lIns="0" tIns="0" rIns="0" bIns="0" rtlCol="0" anchor="t"/>
-          <a:lstStyle/>
-          <a:p>
-            <a:pPr indent="0" marL="0">
-              <a:buNone/>
-            </a:pPr>
-            <a:r>
-              <a:rPr lang="en-US" sz="1600" dirty="0">
-                <a:solidFill>
-                  <a:srgbClr val="5C6F7B"/>
-                </a:solidFill>
-              </a:rPr>
-              <a:t>20 file o 2.000, il codice non cambia.</a:t>
-            </a:r>
-            <a:endParaRPr lang="en-US" sz="1600" dirty="0"/>
-          </a:p>
-        </p:txBody>
-      </p:sp>
-      <p:sp>
-        <p:nvSpPr>
-          <p:cNvPr id="13" name="Shape 9"/>
-          <p:cNvSpPr/>
-          <p:nvPr/>
-        </p:nvSpPr>
-        <p:spPr>
-          <a:xfrm>
-            <a:off x="8107680" y="1737360"/>
-            <a:ext cx="3505200" cy="2926080"/>
-          </a:xfrm>
-          <a:prstGeom prst="roundRect">
-            <a:avLst>
-              <a:gd name="adj" fmla="val 3750"/>
-            </a:avLst>
-          </a:prstGeom>
-          <a:solidFill>
-            <a:srgbClr val="EEF3F4"/>
-          </a:solidFill>
-          <a:ln/>
-        </p:spPr>
-      </p:sp>
-      <p:sp>
-        <p:nvSpPr>
-          <p:cNvPr id="14" name="Shape 10"/>
-          <p:cNvSpPr/>
-          <p:nvPr/>
-        </p:nvSpPr>
-        <p:spPr>
-          <a:xfrm>
-            <a:off x="8382000" y="2011680"/>
-            <a:ext cx="914400" cy="914400"/>
-          </a:xfrm>
-          <a:prstGeom prst="ellipse">
-            <a:avLst/>
-          </a:prstGeom>
-          <a:solidFill>
-            <a:srgbClr val="FFFFFF"/>
-          </a:solidFill>
-          <a:ln/>
-        </p:spPr>
-      </p:sp>
-      <p:pic>
-        <p:nvPicPr>
-          <p:cNvPr id="15" name="Image 2" descr="preencoded.png">    </p:cNvPr>
-          <p:cNvPicPr>
-            <a:picLocks noChangeAspect="1"/>
-          </p:cNvPicPr>
-          <p:nvPr/>
-        </p:nvPicPr>
-        <p:blipFill>
-          <a:blip r:embed="rId3"/>
-          <a:stretch>
-            <a:fillRect/>
-          </a:stretch>
-        </p:blipFill>
-        <p:spPr>
-          <a:xfrm>
-            <a:off x="8628888" y="2258568"/>
-            <a:ext cx="420624" cy="420624"/>
-          </a:xfrm>
-          <a:prstGeom prst="rect">
-            <a:avLst/>
-          </a:prstGeom>
-        </p:spPr>
-      </p:pic>
-      <p:sp>
-        <p:nvSpPr>
-          <p:cNvPr id="16" name="Text 11"/>
-          <p:cNvSpPr txBox="1"/>
-          <p:nvPr/>
-        </p:nvSpPr>
-        <p:spPr>
-          <a:xfrm>
-            <a:off x="8382000" y="3154680"/>
-            <a:ext cx="2956560" cy="502920"/>
-          </a:xfrm>
-          <a:prstGeom prst="rect">
-            <a:avLst/>
-          </a:prstGeom>
-          <a:noFill/>
-          <a:ln/>
-        </p:spPr>
-        <p:txBody>
-          <a:bodyPr wrap="square" lIns="0" tIns="0" rIns="0" bIns="0" rtlCol="0" anchor="ctr"/>
-          <a:lstStyle/>
-          <a:p>
-            <a:pPr indent="0" marL="0">
-              <a:buNone/>
-            </a:pPr>
-            <a:r>
-              <a:rPr lang="en-US" sz="2200" b="1" dirty="0">
+              <a:t>In Molise.xlsx la colonna si chiamava «Fatturato», con la maiuscola.</a:t>
+            </a:r>
+            <a:endParaRPr lang="en-US" sz="1800" dirty="0"/>
+          </a:p>
+          <a:p>
+            <a:pPr indent="0" marL="0">
+              <a:spcAft>
+                <a:spcPts val="1000"/>
+              </a:spcAft>
+              <a:buNone/>
+            </a:pPr>
+            <a:r>
+              <a:rPr lang="en-US" sz="1800" dirty="0">
                 <a:solidFill>
                   <a:srgbClr val="1F2A30"/>
                 </a:solidFill>
               </a:rPr>
-              <a:t>Correggibile</a:t>
-            </a:r>
-            <a:endParaRPr lang="en-US" sz="2200" dirty="0"/>
-          </a:p>
-        </p:txBody>
-      </p:sp>
-      <p:sp>
-        <p:nvSpPr>
-          <p:cNvPr id="17" name="Text 12"/>
-          <p:cNvSpPr txBox="1"/>
-          <p:nvPr/>
-        </p:nvSpPr>
-        <p:spPr>
-          <a:xfrm>
-            <a:off x="8382000" y="3703320"/>
-            <a:ext cx="2956560" cy="777240"/>
-          </a:xfrm>
-          <a:prstGeom prst="rect">
-            <a:avLst/>
-          </a:prstGeom>
-          <a:noFill/>
-          <a:ln/>
-        </p:spPr>
-        <p:txBody>
-          <a:bodyPr wrap="square" lIns="0" tIns="0" rIns="0" bIns="0" rtlCol="0" anchor="t"/>
-          <a:lstStyle/>
-          <a:p>
-            <a:pPr indent="0" marL="0">
-              <a:buNone/>
-            </a:pPr>
-            <a:r>
-              <a:rPr lang="en-US" sz="1600" dirty="0">
-                <a:solidFill>
-                  <a:srgbClr val="5C6F7B"/>
-                </a:solidFill>
-              </a:rPr>
-              <a:t>un errore nella ricetta si corregge in un punto solo.</a:t>
-            </a:r>
-            <a:endParaRPr lang="en-US" sz="1600" dirty="0"/>
+              <a:t>In Excel non ce ne saremmo accorti: avremmo cliccato sulla colonna giusta.</a:t>
+            </a:r>
+            <a:endParaRPr lang="en-US" sz="1800" dirty="0"/>
+          </a:p>
+          <a:p>
+            <a:pPr indent="0" marL="0">
+              <a:spcAft>
+                <a:spcPts val="1000"/>
+              </a:spcAft>
+              <a:buNone/>
+            </a:pPr>
+            <a:r>
+              <a:rPr lang="en-US" sz="1800" b="1" dirty="0">
+                <a:solidFill>
+                  <a:srgbClr val="0F4C5C"/>
+                </a:solidFill>
+              </a:rPr>
+              <a:t>Il codice si è fermato, e ce l'ha detto. Meglio un errore che un risultato sbagliato.</a:t>
+            </a:r>
+            <a:endParaRPr lang="en-US" sz="1800" dirty="0"/>
           </a:p>
         </p:txBody>
       </p:sp>
@@ -3316,6 +2985,528 @@
         </p:nvSpPr>
         <p:spPr>
           <a:xfrm>
+            <a:off x="548640" y="365760"/>
+            <a:ext cx="11064240" cy="822960"/>
+          </a:xfrm>
+          <a:prstGeom prst="rect">
+            <a:avLst/>
+          </a:prstGeom>
+          <a:noFill/>
+          <a:ln/>
+        </p:spPr>
+        <p:txBody>
+          <a:bodyPr wrap="square" lIns="0" tIns="0" rIns="0" bIns="0" rtlCol="0" anchor="ctr"/>
+          <a:lstStyle/>
+          <a:p>
+            <a:pPr algn="l" indent="0" marL="0">
+              <a:buNone/>
+            </a:pPr>
+            <a:r>
+              <a:rPr lang="en-US" sz="3600" b="1" dirty="0">
+                <a:solidFill>
+                  <a:srgbClr val="0F4C5C"/>
+                </a:solidFill>
+              </a:rPr>
+              <a:t>Cosa abbiamo guadagnato</a:t>
+            </a:r>
+            <a:endParaRPr lang="en-US" sz="3600" dirty="0"/>
+          </a:p>
+        </p:txBody>
+      </p:sp>
+      <p:sp>
+        <p:nvSpPr>
+          <p:cNvPr id="3" name="Shape 1"/>
+          <p:cNvSpPr/>
+          <p:nvPr/>
+        </p:nvSpPr>
+        <p:spPr>
+          <a:xfrm>
+            <a:off x="548640" y="1737360"/>
+            <a:ext cx="3505200" cy="2926080"/>
+          </a:xfrm>
+          <a:prstGeom prst="roundRect">
+            <a:avLst>
+              <a:gd name="adj" fmla="val 3750"/>
+            </a:avLst>
+          </a:prstGeom>
+          <a:solidFill>
+            <a:srgbClr val="EEF3F4"/>
+          </a:solidFill>
+          <a:ln/>
+        </p:spPr>
+      </p:sp>
+      <p:sp>
+        <p:nvSpPr>
+          <p:cNvPr id="4" name="Shape 2"/>
+          <p:cNvSpPr/>
+          <p:nvPr/>
+        </p:nvSpPr>
+        <p:spPr>
+          <a:xfrm>
+            <a:off x="822960" y="2011680"/>
+            <a:ext cx="914400" cy="914400"/>
+          </a:xfrm>
+          <a:prstGeom prst="ellipse">
+            <a:avLst/>
+          </a:prstGeom>
+          <a:solidFill>
+            <a:srgbClr val="FFFFFF"/>
+          </a:solidFill>
+          <a:ln/>
+        </p:spPr>
+      </p:sp>
+      <p:pic>
+        <p:nvPicPr>
+          <p:cNvPr id="5" name="Image 0" descr="preencoded.png">    </p:cNvPr>
+          <p:cNvPicPr>
+            <a:picLocks noChangeAspect="1"/>
+          </p:cNvPicPr>
+          <p:nvPr/>
+        </p:nvPicPr>
+        <p:blipFill>
+          <a:blip r:embed="rId1"/>
+          <a:stretch>
+            <a:fillRect/>
+          </a:stretch>
+        </p:blipFill>
+        <p:spPr>
+          <a:xfrm>
+            <a:off x="1069848" y="2258568"/>
+            <a:ext cx="420624" cy="420624"/>
+          </a:xfrm>
+          <a:prstGeom prst="rect">
+            <a:avLst/>
+          </a:prstGeom>
+        </p:spPr>
+      </p:pic>
+      <p:sp>
+        <p:nvSpPr>
+          <p:cNvPr id="6" name="Text 3"/>
+          <p:cNvSpPr txBox="1"/>
+          <p:nvPr/>
+        </p:nvSpPr>
+        <p:spPr>
+          <a:xfrm>
+            <a:off x="822960" y="3154680"/>
+            <a:ext cx="2956560" cy="502920"/>
+          </a:xfrm>
+          <a:prstGeom prst="rect">
+            <a:avLst/>
+          </a:prstGeom>
+          <a:noFill/>
+          <a:ln/>
+        </p:spPr>
+        <p:txBody>
+          <a:bodyPr wrap="square" lIns="0" tIns="0" rIns="0" bIns="0" rtlCol="0" anchor="ctr"/>
+          <a:lstStyle/>
+          <a:p>
+            <a:pPr indent="0" marL="0">
+              <a:buNone/>
+            </a:pPr>
+            <a:r>
+              <a:rPr lang="en-US" sz="2200" b="1" dirty="0">
+                <a:solidFill>
+                  <a:srgbClr val="1F2A30"/>
+                </a:solidFill>
+              </a:rPr>
+              <a:t>Ripetibile</a:t>
+            </a:r>
+            <a:endParaRPr lang="en-US" sz="2200" dirty="0"/>
+          </a:p>
+        </p:txBody>
+      </p:sp>
+      <p:sp>
+        <p:nvSpPr>
+          <p:cNvPr id="7" name="Text 4"/>
+          <p:cNvSpPr txBox="1"/>
+          <p:nvPr/>
+        </p:nvSpPr>
+        <p:spPr>
+          <a:xfrm>
+            <a:off x="822960" y="3703320"/>
+            <a:ext cx="2956560" cy="777240"/>
+          </a:xfrm>
+          <a:prstGeom prst="rect">
+            <a:avLst/>
+          </a:prstGeom>
+          <a:noFill/>
+          <a:ln/>
+        </p:spPr>
+        <p:txBody>
+          <a:bodyPr wrap="square" lIns="0" tIns="0" rIns="0" bIns="0" rtlCol="0" anchor="t"/>
+          <a:lstStyle/>
+          <a:p>
+            <a:pPr indent="0" marL="0">
+              <a:buNone/>
+            </a:pPr>
+            <a:r>
+              <a:rPr lang="en-US" sz="1600" dirty="0">
+                <a:solidFill>
+                  <a:srgbClr val="5C6F7B"/>
+                </a:solidFill>
+              </a:rPr>
+              <a:t>domani arrivano i dati del 2024: rilanci tutto e hai il nuovo report.</a:t>
+            </a:r>
+            <a:endParaRPr lang="en-US" sz="1600" dirty="0"/>
+          </a:p>
+        </p:txBody>
+      </p:sp>
+      <p:sp>
+        <p:nvSpPr>
+          <p:cNvPr id="8" name="Shape 5"/>
+          <p:cNvSpPr/>
+          <p:nvPr/>
+        </p:nvSpPr>
+        <p:spPr>
+          <a:xfrm>
+            <a:off x="4328160" y="1737360"/>
+            <a:ext cx="3505200" cy="2926080"/>
+          </a:xfrm>
+          <a:prstGeom prst="roundRect">
+            <a:avLst>
+              <a:gd name="adj" fmla="val 3750"/>
+            </a:avLst>
+          </a:prstGeom>
+          <a:solidFill>
+            <a:srgbClr val="EEF3F4"/>
+          </a:solidFill>
+          <a:ln/>
+        </p:spPr>
+      </p:sp>
+      <p:sp>
+        <p:nvSpPr>
+          <p:cNvPr id="9" name="Shape 6"/>
+          <p:cNvSpPr/>
+          <p:nvPr/>
+        </p:nvSpPr>
+        <p:spPr>
+          <a:xfrm>
+            <a:off x="4602480" y="2011680"/>
+            <a:ext cx="914400" cy="914400"/>
+          </a:xfrm>
+          <a:prstGeom prst="ellipse">
+            <a:avLst/>
+          </a:prstGeom>
+          <a:solidFill>
+            <a:srgbClr val="FFFFFF"/>
+          </a:solidFill>
+          <a:ln/>
+        </p:spPr>
+      </p:sp>
+      <p:pic>
+        <p:nvPicPr>
+          <p:cNvPr id="10" name="Image 1" descr="preencoded.png">    </p:cNvPr>
+          <p:cNvPicPr>
+            <a:picLocks noChangeAspect="1"/>
+          </p:cNvPicPr>
+          <p:nvPr/>
+        </p:nvPicPr>
+        <p:blipFill>
+          <a:blip r:embed="rId2"/>
+          <a:stretch>
+            <a:fillRect/>
+          </a:stretch>
+        </p:blipFill>
+        <p:spPr>
+          <a:xfrm>
+            <a:off x="4849368" y="2258568"/>
+            <a:ext cx="420624" cy="420624"/>
+          </a:xfrm>
+          <a:prstGeom prst="rect">
+            <a:avLst/>
+          </a:prstGeom>
+        </p:spPr>
+      </p:pic>
+      <p:sp>
+        <p:nvSpPr>
+          <p:cNvPr id="11" name="Text 7"/>
+          <p:cNvSpPr txBox="1"/>
+          <p:nvPr/>
+        </p:nvSpPr>
+        <p:spPr>
+          <a:xfrm>
+            <a:off x="4602480" y="3154680"/>
+            <a:ext cx="2956560" cy="502920"/>
+          </a:xfrm>
+          <a:prstGeom prst="rect">
+            <a:avLst/>
+          </a:prstGeom>
+          <a:noFill/>
+          <a:ln/>
+        </p:spPr>
+        <p:txBody>
+          <a:bodyPr wrap="square" lIns="0" tIns="0" rIns="0" bIns="0" rtlCol="0" anchor="ctr"/>
+          <a:lstStyle/>
+          <a:p>
+            <a:pPr indent="0" marL="0">
+              <a:buNone/>
+            </a:pPr>
+            <a:r>
+              <a:rPr lang="en-US" sz="2200" b="1" dirty="0">
+                <a:solidFill>
+                  <a:srgbClr val="1F2A30"/>
+                </a:solidFill>
+              </a:rPr>
+              <a:t>Scalabile</a:t>
+            </a:r>
+            <a:endParaRPr lang="en-US" sz="2200" dirty="0"/>
+          </a:p>
+        </p:txBody>
+      </p:sp>
+      <p:sp>
+        <p:nvSpPr>
+          <p:cNvPr id="12" name="Text 8"/>
+          <p:cNvSpPr txBox="1"/>
+          <p:nvPr/>
+        </p:nvSpPr>
+        <p:spPr>
+          <a:xfrm>
+            <a:off x="4602480" y="3703320"/>
+            <a:ext cx="2956560" cy="777240"/>
+          </a:xfrm>
+          <a:prstGeom prst="rect">
+            <a:avLst/>
+          </a:prstGeom>
+          <a:noFill/>
+          <a:ln/>
+        </p:spPr>
+        <p:txBody>
+          <a:bodyPr wrap="square" lIns="0" tIns="0" rIns="0" bIns="0" rtlCol="0" anchor="t"/>
+          <a:lstStyle/>
+          <a:p>
+            <a:pPr indent="0" marL="0">
+              <a:buNone/>
+            </a:pPr>
+            <a:r>
+              <a:rPr lang="en-US" sz="1600" dirty="0">
+                <a:solidFill>
+                  <a:srgbClr val="5C6F7B"/>
+                </a:solidFill>
+              </a:rPr>
+              <a:t>20 file o 2.000, il codice non cambia.</a:t>
+            </a:r>
+            <a:endParaRPr lang="en-US" sz="1600" dirty="0"/>
+          </a:p>
+        </p:txBody>
+      </p:sp>
+      <p:sp>
+        <p:nvSpPr>
+          <p:cNvPr id="13" name="Shape 9"/>
+          <p:cNvSpPr/>
+          <p:nvPr/>
+        </p:nvSpPr>
+        <p:spPr>
+          <a:xfrm>
+            <a:off x="8107680" y="1737360"/>
+            <a:ext cx="3505200" cy="2926080"/>
+          </a:xfrm>
+          <a:prstGeom prst="roundRect">
+            <a:avLst>
+              <a:gd name="adj" fmla="val 3750"/>
+            </a:avLst>
+          </a:prstGeom>
+          <a:solidFill>
+            <a:srgbClr val="EEF3F4"/>
+          </a:solidFill>
+          <a:ln/>
+        </p:spPr>
+      </p:sp>
+      <p:sp>
+        <p:nvSpPr>
+          <p:cNvPr id="14" name="Shape 10"/>
+          <p:cNvSpPr/>
+          <p:nvPr/>
+        </p:nvSpPr>
+        <p:spPr>
+          <a:xfrm>
+            <a:off x="8382000" y="2011680"/>
+            <a:ext cx="914400" cy="914400"/>
+          </a:xfrm>
+          <a:prstGeom prst="ellipse">
+            <a:avLst/>
+          </a:prstGeom>
+          <a:solidFill>
+            <a:srgbClr val="FFFFFF"/>
+          </a:solidFill>
+          <a:ln/>
+        </p:spPr>
+      </p:sp>
+      <p:pic>
+        <p:nvPicPr>
+          <p:cNvPr id="15" name="Image 2" descr="preencoded.png">    </p:cNvPr>
+          <p:cNvPicPr>
+            <a:picLocks noChangeAspect="1"/>
+          </p:cNvPicPr>
+          <p:nvPr/>
+        </p:nvPicPr>
+        <p:blipFill>
+          <a:blip r:embed="rId3"/>
+          <a:stretch>
+            <a:fillRect/>
+          </a:stretch>
+        </p:blipFill>
+        <p:spPr>
+          <a:xfrm>
+            <a:off x="8628888" y="2258568"/>
+            <a:ext cx="420624" cy="420624"/>
+          </a:xfrm>
+          <a:prstGeom prst="rect">
+            <a:avLst/>
+          </a:prstGeom>
+        </p:spPr>
+      </p:pic>
+      <p:sp>
+        <p:nvSpPr>
+          <p:cNvPr id="16" name="Text 11"/>
+          <p:cNvSpPr txBox="1"/>
+          <p:nvPr/>
+        </p:nvSpPr>
+        <p:spPr>
+          <a:xfrm>
+            <a:off x="8382000" y="3154680"/>
+            <a:ext cx="2956560" cy="502920"/>
+          </a:xfrm>
+          <a:prstGeom prst="rect">
+            <a:avLst/>
+          </a:prstGeom>
+          <a:noFill/>
+          <a:ln/>
+        </p:spPr>
+        <p:txBody>
+          <a:bodyPr wrap="square" lIns="0" tIns="0" rIns="0" bIns="0" rtlCol="0" anchor="ctr"/>
+          <a:lstStyle/>
+          <a:p>
+            <a:pPr indent="0" marL="0">
+              <a:buNone/>
+            </a:pPr>
+            <a:r>
+              <a:rPr lang="en-US" sz="2200" b="1" dirty="0">
+                <a:solidFill>
+                  <a:srgbClr val="1F2A30"/>
+                </a:solidFill>
+              </a:rPr>
+              <a:t>Correggibile</a:t>
+            </a:r>
+            <a:endParaRPr lang="en-US" sz="2200" dirty="0"/>
+          </a:p>
+        </p:txBody>
+      </p:sp>
+      <p:sp>
+        <p:nvSpPr>
+          <p:cNvPr id="17" name="Text 12"/>
+          <p:cNvSpPr txBox="1"/>
+          <p:nvPr/>
+        </p:nvSpPr>
+        <p:spPr>
+          <a:xfrm>
+            <a:off x="8382000" y="3703320"/>
+            <a:ext cx="2956560" cy="777240"/>
+          </a:xfrm>
+          <a:prstGeom prst="rect">
+            <a:avLst/>
+          </a:prstGeom>
+          <a:noFill/>
+          <a:ln/>
+        </p:spPr>
+        <p:txBody>
+          <a:bodyPr wrap="square" lIns="0" tIns="0" rIns="0" bIns="0" rtlCol="0" anchor="t"/>
+          <a:lstStyle/>
+          <a:p>
+            <a:pPr indent="0" marL="0">
+              <a:buNone/>
+            </a:pPr>
+            <a:r>
+              <a:rPr lang="en-US" sz="1600" dirty="0">
+                <a:solidFill>
+                  <a:srgbClr val="5C6F7B"/>
+                </a:solidFill>
+              </a:rPr>
+              <a:t>un errore nella ricetta si corregge in un punto solo.</a:t>
+            </a:r>
+            <a:endParaRPr lang="en-US" sz="1600" dirty="0"/>
+          </a:p>
+        </p:txBody>
+      </p:sp>
+      <p:sp>
+        <p:nvSpPr>
+          <p:cNvPr id="25" name="Slide Number Placeholder 0"/>
+          <p:cNvSpPr>
+            <a:spLocks noGrp="1"/>
+          </p:cNvSpPr>
+          <p:nvPr>
+            <p:ph type="sldNum" sz="quarter" idx="4294967295"/>
+          </p:nvPr>
+        </p:nvSpPr>
+        <p:spPr>
+          <a:xfrm>
+            <a:off x="11155680" y="6400800"/>
+            <a:ext cx="457200" cy="274320"/>
+          </a:xfrm>
+          <a:prstGeom prst="rect">
+            <a:avLst/>
+          </a:prstGeom>
+          <a:extLst>
+            <a:ext uri="{C572A759-6A51-4108-AA02-DFA0A04FC94B}">
+              <ma14:wrappingTextBoxFlag xmlns:ma14="http://schemas.microsoft.com/office/mac/drawingml/2011/main" val="0"/>
+            </a:ext>
+          </a:extLst>
+        </p:spPr>
+        <p:txBody>
+          <a:bodyPr/>
+          <a:lstStyle>
+            <a:lvl1pPr>
+              <a:defRPr sz="1000">
+                <a:solidFill>
+                  <a:srgbClr val="5C6F7B"/>
+                </a:solidFill>
+              </a:defRPr>
+            </a:lvl1pPr>
+          </a:lstStyle>
+          <a:p>
+            <a:pPr algn="r"/>
+            <a:fld id="{F7021451-1387-4CA6-816F-3879F97B5CBC}" type="slidenum">
+              <a:rPr b="0" lang="en-US"/>
+              <a:t>12</a:t>
+            </a:fld>
+            <a:endParaRPr lang="en-US"/>
+          </a:p>
+        </p:txBody>
+      </p:sp>
+    </p:spTree>
+  </p:cSld>
+  <p:clrMapOvr>
+    <a:masterClrMapping/>
+  </p:clrMapOvr>
+</p:sld>
+</file>
+
+<file path=ppt/slides/slide13.xml><?xml version="1.0" encoding="utf-8"?>
+<p:sld xmlns:a="http://schemas.openxmlformats.org/drawingml/2006/main" xmlns:r="http://schemas.openxmlformats.org/officeDocument/2006/relationships" xmlns:p="http://schemas.openxmlformats.org/presentationml/2006/main">
+  <p:cSld name="Slide 13">
+    <p:spTree>
+      <p:nvGrpSpPr>
+        <p:cNvPr id="1" name=""/>
+        <p:cNvGrpSpPr/>
+        <p:nvPr/>
+      </p:nvGrpSpPr>
+      <p:grpSpPr>
+        <a:xfrm>
+          <a:off x="0" y="0"/>
+          <a:ext cx="0" cy="0"/>
+          <a:chOff x="0" y="0"/>
+          <a:chExt cx="0" cy="0"/>
+        </a:xfrm>
+      </p:grpSpPr>
+      <p:sp>
+        <p:nvSpPr>
+          <p:cNvPr id="2" name="Text 0"/>
+          <p:cNvSpPr/>
+          <p:nvPr>
+            <p:ph idx="100" type="title" hasCustomPrompt="1"/>
+          </p:nvPr>
+        </p:nvSpPr>
+        <p:spPr>
+          <a:xfrm>
             <a:off x="731520" y="2103120"/>
             <a:ext cx="10698480" cy="1463040"/>
           </a:xfrm>
@@ -5522,7 +5713,7 @@
                   <a:srgbClr val="0F4C5C"/>
                 </a:solidFill>
               </a:rPr>
-              <a:t>Funzione + ciclo + cartella</a:t>
+              <a:t>Blocchi e rientro</a:t>
             </a:r>
             <a:endParaRPr lang="en-US" sz="3600" dirty="0"/>
           </a:p>
@@ -5537,11 +5728,11 @@
         <p:spPr>
           <a:xfrm>
             <a:off x="548640" y="1737360"/>
-            <a:ext cx="7315200" cy="2926080"/>
+            <a:ext cx="6766560" cy="2743200"/>
           </a:xfrm>
           <a:prstGeom prst="roundRect">
             <a:avLst>
-              <a:gd name="adj" fmla="val 3750"/>
+              <a:gd name="adj" fmla="val 4000"/>
             </a:avLst>
           </a:prstGeom>
           <a:solidFill>
@@ -5595,7 +5786,7 @@
         <p:spPr>
           <a:xfrm>
             <a:off x="777240" y="2194560"/>
-            <a:ext cx="6858000" cy="2331720"/>
+            <a:ext cx="6309360" cy="2148840"/>
           </a:xfrm>
           <a:prstGeom prst="rect">
             <a:avLst/>
@@ -5611,7 +5802,7 @@
               <a:buNone/>
             </a:pPr>
             <a:r>
-              <a:rPr lang="en-US" sz="1600" dirty="0">
+              <a:rPr lang="en-US" sz="1700" dirty="0">
                 <a:solidFill>
                   <a:srgbClr val="FFFFFF"/>
                 </a:solidFill>
@@ -5619,22 +5810,16 @@
                 <a:ea typeface="Courier New" pitchFamily="34" charset="-122"/>
                 <a:cs typeface="Courier New" pitchFamily="34" charset="-120"/>
               </a:rPr>
-              <a:t>from pathlib import Path</a:t>
-            </a:r>
-            <a:endParaRPr lang="en-US" sz="1600" dirty="0"/>
-          </a:p>
-          <a:p>
-            <a:pPr indent="0" marL="0">
-              <a:buNone/>
-            </a:pPr>
-            <a:endParaRPr lang="en-US" sz="1600" dirty="0"/>
-          </a:p>
-          <a:p>
-            <a:pPr indent="0" marL="0">
-              <a:buNone/>
-            </a:pPr>
-            <a:r>
-              <a:rPr lang="en-US" sz="1600" dirty="0">
+              <a:t>for f in file:</a:t>
+            </a:r>
+            <a:endParaRPr lang="en-US" sz="1700" dirty="0"/>
+          </a:p>
+          <a:p>
+            <a:pPr indent="0" marL="0">
+              <a:buNone/>
+            </a:pPr>
+            <a:r>
+              <a:rPr lang="en-US" sz="1700" dirty="0">
                 <a:solidFill>
                   <a:srgbClr val="FFFFFF"/>
                 </a:solidFill>
@@ -5642,16 +5827,16 @@
                 <a:ea typeface="Courier New" pitchFamily="34" charset="-122"/>
                 <a:cs typeface="Courier New" pitchFamily="34" charset="-120"/>
               </a:rPr>
-              <a:t>file = sorted(Path("dati").glob("*.xlsx"))</a:t>
-            </a:r>
-            <a:endParaRPr lang="en-US" sz="1600" dirty="0"/>
-          </a:p>
-          <a:p>
-            <a:pPr indent="0" marL="0">
-              <a:buNone/>
-            </a:pPr>
-            <a:r>
-              <a:rPr lang="en-US" sz="1600" dirty="0">
+              <a:t>    d = pd.read_excel(f)</a:t>
+            </a:r>
+            <a:endParaRPr lang="en-US" sz="1700" dirty="0"/>
+          </a:p>
+          <a:p>
+            <a:pPr indent="0" marL="0">
+              <a:buNone/>
+            </a:pPr>
+            <a:r>
+              <a:rPr lang="en-US" sz="1700" dirty="0">
                 <a:solidFill>
                   <a:srgbClr val="FFFFFF"/>
                 </a:solidFill>
@@ -5659,16 +5844,16 @@
                 <a:ea typeface="Courier New" pitchFamily="34" charset="-122"/>
                 <a:cs typeface="Courier New" pitchFamily="34" charset="-120"/>
               </a:rPr>
-              <a:t>risultati = []</a:t>
-            </a:r>
-            <a:endParaRPr lang="en-US" sz="1600" dirty="0"/>
-          </a:p>
-          <a:p>
-            <a:pPr indent="0" marL="0">
-              <a:buNone/>
-            </a:pPr>
-            <a:r>
-              <a:rPr lang="en-US" sz="1600" dirty="0">
+              <a:t>    if len(d) &lt; 10:</a:t>
+            </a:r>
+            <a:endParaRPr lang="en-US" sz="1700" dirty="0"/>
+          </a:p>
+          <a:p>
+            <a:pPr indent="0" marL="0">
+              <a:buNone/>
+            </a:pPr>
+            <a:r>
+              <a:rPr lang="en-US" sz="1700" dirty="0">
                 <a:solidFill>
                   <a:srgbClr val="FFFFFF"/>
                 </a:solidFill>
@@ -5676,16 +5861,16 @@
                 <a:ea typeface="Courier New" pitchFamily="34" charset="-122"/>
                 <a:cs typeface="Courier New" pitchFamily="34" charset="-120"/>
               </a:rPr>
-              <a:t>for f in file:</a:t>
-            </a:r>
-            <a:endParaRPr lang="en-US" sz="1600" dirty="0"/>
-          </a:p>
-          <a:p>
-            <a:pPr indent="0" marL="0">
-              <a:buNone/>
-            </a:pPr>
-            <a:r>
-              <a:rPr lang="en-US" sz="1600" dirty="0">
+              <a:t>        print(f.stem, "poco affidabile")</a:t>
+            </a:r>
+            <a:endParaRPr lang="en-US" sz="1700" dirty="0"/>
+          </a:p>
+          <a:p>
+            <a:pPr indent="0" marL="0">
+              <a:buNone/>
+            </a:pPr>
+            <a:r>
+              <a:rPr lang="en-US" sz="1700" dirty="0">
                 <a:solidFill>
                   <a:srgbClr val="FFFFFF"/>
                 </a:solidFill>
@@ -5693,26 +5878,9 @@
                 <a:ea typeface="Courier New" pitchFamily="34" charset="-122"/>
                 <a:cs typeface="Courier New" pitchFamily="34" charset="-120"/>
               </a:rPr>
-              <a:t>    risultati.append(riepilogo(f))</a:t>
-            </a:r>
-            <a:endParaRPr lang="en-US" sz="1600" dirty="0"/>
-          </a:p>
-          <a:p>
-            <a:pPr indent="0" marL="0">
-              <a:buNone/>
-            </a:pPr>
-            <a:r>
-              <a:rPr lang="en-US" sz="1600" dirty="0">
-                <a:solidFill>
-                  <a:srgbClr val="FFFFFF"/>
-                </a:solidFill>
-                <a:latin typeface="Courier New" pitchFamily="34" charset="0"/>
-                <a:ea typeface="Courier New" pitchFamily="34" charset="-122"/>
-                <a:cs typeface="Courier New" pitchFamily="34" charset="-120"/>
-              </a:rPr>
-              <a:t>tab = pd.DataFrame(risultati)</a:t>
-            </a:r>
-            <a:endParaRPr lang="en-US" sz="1600" dirty="0"/>
+              <a:t>print("fatto")</a:t>
+            </a:r>
+            <a:endParaRPr lang="en-US" sz="1700" dirty="0"/>
           </a:p>
         </p:txBody>
       </p:sp>
@@ -5724,8 +5892,8 @@
         </p:nvSpPr>
         <p:spPr>
           <a:xfrm>
-            <a:off x="8229600" y="1828800"/>
-            <a:ext cx="3383280" cy="3840480"/>
+            <a:off x="7680960" y="1828800"/>
+            <a:ext cx="3931920" cy="4023360"/>
           </a:xfrm>
           <a:prstGeom prst="rect">
             <a:avLst/>
@@ -5750,7 +5918,7 @@
                   <a:srgbClr val="1F2A30"/>
                 </a:solidFill>
               </a:rPr>
-              <a:t>glob trova tutti i file che corrispondono a uno schema</a:t>
+              <a:t>I due punti aprono un blocco</a:t>
             </a:r>
             <a:endParaRPr lang="en-US" sz="1700" dirty="0"/>
           </a:p>
@@ -5768,7 +5936,7 @@
                   <a:srgbClr val="1F2A30"/>
                 </a:solidFill>
               </a:rPr>
-              <a:t>Ogni giro: un file, un riepilogo, aggiunto alla lista</a:t>
+              <a:t>Il rientro (4 spazi, tasto Tab) dice cosa ne fa parte</a:t>
             </a:r>
             <a:endParaRPr lang="en-US" sz="1700" dirty="0"/>
           </a:p>
@@ -5786,7 +5954,7 @@
                   <a:srgbClr val="1F2A30"/>
                 </a:solidFill>
               </a:rPr>
-              <a:t>Alla fine la lista diventa una tabella</a:t>
+              <a:t>Il blocco finisce quando si torna a sinistra</a:t>
             </a:r>
             <a:endParaRPr lang="en-US" sz="1700" dirty="0"/>
           </a:p>
@@ -5799,50 +5967,32 @@
               <a:buChar char="•"/>
             </a:pPr>
             <a:r>
+              <a:rPr lang="en-US" sz="1700" dirty="0">
+                <a:solidFill>
+                  <a:srgbClr val="1F2A30"/>
+                </a:solidFill>
+              </a:rPr>
+              <a:t>Dentro le parentesi il rientro non conta: è solo per leggere meglio</a:t>
+            </a:r>
+            <a:endParaRPr lang="en-US" sz="1700" dirty="0"/>
+          </a:p>
+          <a:p>
+            <a:pPr marL="342900" indent="-342900">
+              <a:spcAft>
+                <a:spcPts val="1000"/>
+              </a:spcAft>
+              <a:buSzPct val="100000"/>
+              <a:buChar char="•"/>
+            </a:pPr>
+            <a:r>
               <a:rPr lang="en-US" sz="1700" b="1" dirty="0">
                 <a:solidFill>
                   <a:srgbClr val="0F4C5C"/>
                 </a:solidFill>
               </a:rPr>
-              <a:t>20 file o 2.000: stesso codice</a:t>
+              <a:t>Rientro sbagliato? IndentationError</a:t>
             </a:r>
             <a:endParaRPr lang="en-US" sz="1700" dirty="0"/>
-          </a:p>
-        </p:txBody>
-      </p:sp>
-      <p:sp>
-        <p:nvSpPr>
-          <p:cNvPr id="7" name="Text 5"/>
-          <p:cNvSpPr txBox="1"/>
-          <p:nvPr/>
-        </p:nvSpPr>
-        <p:spPr>
-          <a:xfrm>
-            <a:off x="548640" y="5029200"/>
-            <a:ext cx="11064240" cy="457200"/>
-          </a:xfrm>
-          <a:prstGeom prst="rect">
-            <a:avLst/>
-          </a:prstGeom>
-          <a:noFill/>
-          <a:ln/>
-        </p:spPr>
-        <p:txBody>
-          <a:bodyPr wrap="square" lIns="0" tIns="0" rIns="0" bIns="0" rtlCol="0" anchor="ctr"/>
-          <a:lstStyle/>
-          <a:p>
-            <a:pPr indent="0" marL="0">
-              <a:buNone/>
-            </a:pPr>
-            <a:r>
-              <a:rPr lang="en-US" sz="1800" i="1" dirty="0">
-                <a:solidFill>
-                  <a:srgbClr val="0F4C5C"/>
-                </a:solidFill>
-              </a:rPr>
-              <a:t>In Colab i file del corso si scaricano con git clone: compaiono nel pannello a sinistra.</a:t>
-            </a:r>
-            <a:endParaRPr lang="en-US" sz="1800" dirty="0"/>
           </a:p>
         </p:txBody>
       </p:sp>
@@ -5948,7 +6098,7 @@
                   <a:srgbClr val="0F4C5C"/>
                 </a:solidFill>
               </a:rPr>
-              <a:t>Quando un ciclo si ferma</a:t>
+              <a:t>Funzione + ciclo + cartella</a:t>
             </a:r>
             <a:endParaRPr lang="en-US" sz="3600" dirty="0"/>
           </a:p>
@@ -5956,22 +6106,22 @@
       </p:sp>
       <p:sp>
         <p:nvSpPr>
-          <p:cNvPr id="3" name="Shape 1"/>
+          <p:cNvPr id="3" name="card-code"/>
           <p:cNvSpPr/>
           <p:nvPr/>
         </p:nvSpPr>
         <p:spPr>
           <a:xfrm>
             <a:off x="548640" y="1737360"/>
-            <a:ext cx="5394960" cy="2743200"/>
+            <a:ext cx="7315200" cy="2926080"/>
           </a:xfrm>
           <a:prstGeom prst="roundRect">
             <a:avLst>
-              <a:gd name="adj" fmla="val 4000"/>
+              <a:gd name="adj" fmla="val 3750"/>
             </a:avLst>
           </a:prstGeom>
           <a:solidFill>
-            <a:srgbClr val="EEF3F4"/>
+            <a:srgbClr val="1F2A30"/>
           </a:solidFill>
           <a:ln/>
         </p:spPr>
@@ -5984,8 +6134,8 @@
         </p:nvSpPr>
         <p:spPr>
           <a:xfrm>
-            <a:off x="822960" y="1965960"/>
-            <a:ext cx="4846320" cy="365760"/>
+            <a:off x="777240" y="1874520"/>
+            <a:ext cx="1828800" cy="274320"/>
           </a:xfrm>
           <a:prstGeom prst="rect">
             <a:avLst/>
@@ -6001,14 +6151,14 @@
               <a:buNone/>
             </a:pPr>
             <a:r>
-              <a:rPr lang="en-US" sz="1300" b="1" spc="200" kern="0" dirty="0">
-                <a:solidFill>
-                  <a:srgbClr val="8F5308"/>
-                </a:solidFill>
-              </a:rPr>
-              <a:t>IL TRUCCO</a:t>
-            </a:r>
-            <a:endParaRPr lang="en-US" sz="1300" dirty="0"/>
+              <a:rPr lang="en-US" sz="1100" b="1" spc="200" kern="0" dirty="0">
+                <a:solidFill>
+                  <a:srgbClr val="E09F3E"/>
+                </a:solidFill>
+              </a:rPr>
+              <a:t>PYTHON</a:t>
+            </a:r>
+            <a:endParaRPr lang="en-US" sz="1100" dirty="0"/>
           </a:p>
         </p:txBody>
       </p:sp>
@@ -6020,8 +6170,8 @@
         </p:nvSpPr>
         <p:spPr>
           <a:xfrm>
-            <a:off x="822960" y="2423160"/>
-            <a:ext cx="4846320" cy="1874520"/>
+            <a:off x="777240" y="2194560"/>
+            <a:ext cx="6858000" cy="2331720"/>
           </a:xfrm>
           <a:prstGeom prst="rect">
             <a:avLst/>
@@ -6037,38 +6187,204 @@
               <a:buNone/>
             </a:pPr>
             <a:r>
-              <a:rPr lang="en-US" sz="1900" dirty="0">
+              <a:rPr lang="en-US" sz="1600" dirty="0">
+                <a:solidFill>
+                  <a:srgbClr val="FFFFFF"/>
+                </a:solidFill>
+                <a:latin typeface="Courier New" pitchFamily="34" charset="0"/>
+                <a:ea typeface="Courier New" pitchFamily="34" charset="-122"/>
+                <a:cs typeface="Courier New" pitchFamily="34" charset="-120"/>
+              </a:rPr>
+              <a:t>from pathlib import Path</a:t>
+            </a:r>
+            <a:endParaRPr lang="en-US" sz="1600" dirty="0"/>
+          </a:p>
+          <a:p>
+            <a:pPr indent="0" marL="0">
+              <a:buNone/>
+            </a:pPr>
+            <a:endParaRPr lang="en-US" sz="1600" dirty="0"/>
+          </a:p>
+          <a:p>
+            <a:pPr indent="0" marL="0">
+              <a:buNone/>
+            </a:pPr>
+            <a:r>
+              <a:rPr lang="en-US" sz="1600" dirty="0">
+                <a:solidFill>
+                  <a:srgbClr val="FFFFFF"/>
+                </a:solidFill>
+                <a:latin typeface="Courier New" pitchFamily="34" charset="0"/>
+                <a:ea typeface="Courier New" pitchFamily="34" charset="-122"/>
+                <a:cs typeface="Courier New" pitchFamily="34" charset="-120"/>
+              </a:rPr>
+              <a:t>file = sorted(Path("dati").glob("*.xlsx"))</a:t>
+            </a:r>
+            <a:endParaRPr lang="en-US" sz="1600" dirty="0"/>
+          </a:p>
+          <a:p>
+            <a:pPr indent="0" marL="0">
+              <a:buNone/>
+            </a:pPr>
+            <a:r>
+              <a:rPr lang="en-US" sz="1600" dirty="0">
+                <a:solidFill>
+                  <a:srgbClr val="FFFFFF"/>
+                </a:solidFill>
+                <a:latin typeface="Courier New" pitchFamily="34" charset="0"/>
+                <a:ea typeface="Courier New" pitchFamily="34" charset="-122"/>
+                <a:cs typeface="Courier New" pitchFamily="34" charset="-120"/>
+              </a:rPr>
+              <a:t>risultati = []</a:t>
+            </a:r>
+            <a:endParaRPr lang="en-US" sz="1600" dirty="0"/>
+          </a:p>
+          <a:p>
+            <a:pPr indent="0" marL="0">
+              <a:buNone/>
+            </a:pPr>
+            <a:r>
+              <a:rPr lang="en-US" sz="1600" dirty="0">
+                <a:solidFill>
+                  <a:srgbClr val="FFFFFF"/>
+                </a:solidFill>
+                <a:latin typeface="Courier New" pitchFamily="34" charset="0"/>
+                <a:ea typeface="Courier New" pitchFamily="34" charset="-122"/>
+                <a:cs typeface="Courier New" pitchFamily="34" charset="-120"/>
+              </a:rPr>
+              <a:t>for f in file:</a:t>
+            </a:r>
+            <a:endParaRPr lang="en-US" sz="1600" dirty="0"/>
+          </a:p>
+          <a:p>
+            <a:pPr indent="0" marL="0">
+              <a:buNone/>
+            </a:pPr>
+            <a:r>
+              <a:rPr lang="en-US" sz="1600" dirty="0">
+                <a:solidFill>
+                  <a:srgbClr val="FFFFFF"/>
+                </a:solidFill>
+                <a:latin typeface="Courier New" pitchFamily="34" charset="0"/>
+                <a:ea typeface="Courier New" pitchFamily="34" charset="-122"/>
+                <a:cs typeface="Courier New" pitchFamily="34" charset="-120"/>
+              </a:rPr>
+              <a:t>    risultati.append(riepilogo(f))</a:t>
+            </a:r>
+            <a:endParaRPr lang="en-US" sz="1600" dirty="0"/>
+          </a:p>
+          <a:p>
+            <a:pPr indent="0" marL="0">
+              <a:buNone/>
+            </a:pPr>
+            <a:r>
+              <a:rPr lang="en-US" sz="1600" dirty="0">
+                <a:solidFill>
+                  <a:srgbClr val="FFFFFF"/>
+                </a:solidFill>
+                <a:latin typeface="Courier New" pitchFamily="34" charset="0"/>
+                <a:ea typeface="Courier New" pitchFamily="34" charset="-122"/>
+                <a:cs typeface="Courier New" pitchFamily="34" charset="-120"/>
+              </a:rPr>
+              <a:t>tab = pd.DataFrame(risultati)</a:t>
+            </a:r>
+            <a:endParaRPr lang="en-US" sz="1600" dirty="0"/>
+          </a:p>
+        </p:txBody>
+      </p:sp>
+      <p:sp>
+        <p:nvSpPr>
+          <p:cNvPr id="6" name="Text 4"/>
+          <p:cNvSpPr txBox="1"/>
+          <p:nvPr/>
+        </p:nvSpPr>
+        <p:spPr>
+          <a:xfrm>
+            <a:off x="8229600" y="1828800"/>
+            <a:ext cx="3383280" cy="3840480"/>
+          </a:xfrm>
+          <a:prstGeom prst="rect">
+            <a:avLst/>
+          </a:prstGeom>
+          <a:noFill/>
+          <a:ln/>
+        </p:spPr>
+        <p:txBody>
+          <a:bodyPr wrap="square" lIns="0" tIns="0" rIns="0" bIns="0" rtlCol="0" anchor="t"/>
+          <a:lstStyle/>
+          <a:p>
+            <a:pPr marL="342900" indent="-342900">
+              <a:spcAft>
+                <a:spcPts val="1000"/>
+              </a:spcAft>
+              <a:buSzPct val="100000"/>
+              <a:buChar char="•"/>
+            </a:pPr>
+            <a:r>
+              <a:rPr lang="en-US" sz="1700" dirty="0">
                 <a:solidFill>
                   <a:srgbClr val="1F2A30"/>
                 </a:solidFill>
               </a:rPr>
-              <a:t>Stampa il nome del file prima di elaborarlo. Se si ferma con un errore, l'ultimo nome stampato è il colpevole.</a:t>
-            </a:r>
-            <a:endParaRPr lang="en-US" sz="1900" dirty="0"/>
-          </a:p>
-        </p:txBody>
-      </p:sp>
-      <p:sp>
-        <p:nvSpPr>
-          <p:cNvPr id="6" name="Shape 4"/>
-          <p:cNvSpPr/>
-          <p:nvPr/>
-        </p:nvSpPr>
-        <p:spPr>
-          <a:xfrm>
-            <a:off x="6217920" y="1737360"/>
-            <a:ext cx="5394960" cy="2743200"/>
-          </a:xfrm>
-          <a:prstGeom prst="roundRect">
-            <a:avLst>
-              <a:gd name="adj" fmla="val 4000"/>
-            </a:avLst>
-          </a:prstGeom>
-          <a:solidFill>
-            <a:srgbClr val="0F4C5C"/>
-          </a:solidFill>
-          <a:ln/>
-        </p:spPr>
+              <a:t>glob trova tutti i file che corrispondono a uno schema</a:t>
+            </a:r>
+            <a:endParaRPr lang="en-US" sz="1700" dirty="0"/>
+          </a:p>
+          <a:p>
+            <a:pPr marL="342900" indent="-342900">
+              <a:spcAft>
+                <a:spcPts val="1000"/>
+              </a:spcAft>
+              <a:buSzPct val="100000"/>
+              <a:buChar char="•"/>
+            </a:pPr>
+            <a:r>
+              <a:rPr lang="en-US" sz="1700" dirty="0">
+                <a:solidFill>
+                  <a:srgbClr val="1F2A30"/>
+                </a:solidFill>
+              </a:rPr>
+              <a:t>Ogni giro: un file, un riepilogo, aggiunto alla lista</a:t>
+            </a:r>
+            <a:endParaRPr lang="en-US" sz="1700" dirty="0"/>
+          </a:p>
+          <a:p>
+            <a:pPr marL="342900" indent="-342900">
+              <a:spcAft>
+                <a:spcPts val="1000"/>
+              </a:spcAft>
+              <a:buSzPct val="100000"/>
+              <a:buChar char="•"/>
+            </a:pPr>
+            <a:r>
+              <a:rPr lang="en-US" sz="1700" dirty="0">
+                <a:solidFill>
+                  <a:srgbClr val="1F2A30"/>
+                </a:solidFill>
+              </a:rPr>
+              <a:t>Alla fine la lista diventa una tabella</a:t>
+            </a:r>
+            <a:endParaRPr lang="en-US" sz="1700" dirty="0"/>
+          </a:p>
+          <a:p>
+            <a:pPr marL="342900" indent="-342900">
+              <a:spcAft>
+                <a:spcPts val="1000"/>
+              </a:spcAft>
+              <a:buSzPct val="100000"/>
+              <a:buChar char="•"/>
+            </a:pPr>
+            <a:r>
+              <a:rPr lang="en-US" sz="1700" b="1" dirty="0">
+                <a:solidFill>
+                  <a:srgbClr val="0F4C5C"/>
+                </a:solidFill>
+              </a:rPr>
+              <a:t>20 file o 2.000: stesso codice</a:t>
+            </a:r>
+            <a:endParaRPr lang="en-US" sz="1700" dirty="0"/>
+          </a:p>
+        </p:txBody>
       </p:sp>
       <p:sp>
         <p:nvSpPr>
@@ -6078,8 +6394,8 @@
         </p:nvSpPr>
         <p:spPr>
           <a:xfrm>
-            <a:off x="6492240" y="1965960"/>
-            <a:ext cx="4846320" cy="365760"/>
+            <a:off x="548640" y="5029200"/>
+            <a:ext cx="11064240" cy="457200"/>
           </a:xfrm>
           <a:prstGeom prst="rect">
             <a:avLst/>
@@ -6095,84 +6411,12 @@
               <a:buNone/>
             </a:pPr>
             <a:r>
-              <a:rPr lang="en-US" sz="1300" b="1" spc="200" kern="0" dirty="0">
-                <a:solidFill>
-                  <a:srgbClr val="F4C06E"/>
-                </a:solidFill>
-              </a:rPr>
-              <a:t>POI</a:t>
-            </a:r>
-            <a:endParaRPr lang="en-US" sz="1300" dirty="0"/>
-          </a:p>
-        </p:txBody>
-      </p:sp>
-      <p:sp>
-        <p:nvSpPr>
-          <p:cNvPr id="8" name="Text 6"/>
-          <p:cNvSpPr txBox="1"/>
-          <p:nvPr/>
-        </p:nvSpPr>
-        <p:spPr>
-          <a:xfrm>
-            <a:off x="6492240" y="2423160"/>
-            <a:ext cx="4846320" cy="1874520"/>
-          </a:xfrm>
-          <a:prstGeom prst="rect">
-            <a:avLst/>
-          </a:prstGeom>
-          <a:noFill/>
-          <a:ln/>
-        </p:spPr>
-        <p:txBody>
-          <a:bodyPr wrap="square" lIns="0" tIns="0" rIns="0" bIns="0" rtlCol="0" anchor="t"/>
-          <a:lstStyle/>
-          <a:p>
-            <a:pPr indent="0" marL="0">
-              <a:buNone/>
-            </a:pPr>
-            <a:r>
-              <a:rPr lang="en-US" sz="1900" dirty="0">
-                <a:solidFill>
-                  <a:srgbClr val="FFFFFF"/>
-                </a:solidFill>
-              </a:rPr>
-              <a:t>Apri quel file e guardalo: cosa ha di diverso dagli altri? Correggi la funzione in modo che regga anche quel caso.</a:t>
-            </a:r>
-            <a:endParaRPr lang="en-US" sz="1900" dirty="0"/>
-          </a:p>
-        </p:txBody>
-      </p:sp>
-      <p:sp>
-        <p:nvSpPr>
-          <p:cNvPr id="9" name="Text 7"/>
-          <p:cNvSpPr txBox="1"/>
-          <p:nvPr/>
-        </p:nvSpPr>
-        <p:spPr>
-          <a:xfrm>
-            <a:off x="548640" y="4846320"/>
-            <a:ext cx="11064240" cy="457200"/>
-          </a:xfrm>
-          <a:prstGeom prst="rect">
-            <a:avLst/>
-          </a:prstGeom>
-          <a:noFill/>
-          <a:ln/>
-        </p:spPr>
-        <p:txBody>
-          <a:bodyPr wrap="square" lIns="0" tIns="0" rIns="0" bIns="0" rtlCol="0" anchor="ctr"/>
-          <a:lstStyle/>
-          <a:p>
-            <a:pPr indent="0" marL="0">
-              <a:buNone/>
-            </a:pPr>
-            <a:r>
               <a:rPr lang="en-US" sz="1800" i="1" dirty="0">
                 <a:solidFill>
                   <a:srgbClr val="0F4C5C"/>
                 </a:solidFill>
               </a:rPr>
-              <a:t>I file «tutti uguali» non sono mai tutti uguali.</a:t>
+              <a:t>In Colab i file del corso si scaricano con git clone: compaiono nel pannello a sinistra.</a:t>
             </a:r>
             <a:endParaRPr lang="en-US" sz="1800" dirty="0"/>
           </a:p>
@@ -6258,83 +6502,300 @@
         </p:nvSpPr>
         <p:spPr>
           <a:xfrm>
-            <a:off x="731520" y="2194560"/>
-            <a:ext cx="10698480" cy="1280160"/>
-          </a:xfrm>
-          <a:prstGeom prst="rect">
-            <a:avLst/>
-          </a:prstGeom>
-          <a:noFill/>
-          <a:ln/>
-        </p:spPr>
-        <p:txBody>
-          <a:bodyPr wrap="square" lIns="0" tIns="0" rIns="0" bIns="0" rtlCol="0" anchor="b"/>
+            <a:off x="548640" y="365760"/>
+            <a:ext cx="11064240" cy="822960"/>
+          </a:xfrm>
+          <a:prstGeom prst="rect">
+            <a:avLst/>
+          </a:prstGeom>
+          <a:noFill/>
+          <a:ln/>
+        </p:spPr>
+        <p:txBody>
+          <a:bodyPr wrap="square" lIns="0" tIns="0" rIns="0" bIns="0" rtlCol="0" anchor="ctr"/>
           <a:lstStyle/>
           <a:p>
             <a:pPr algn="l" indent="0" marL="0">
               <a:buNone/>
             </a:pPr>
             <a:r>
-              <a:rPr lang="en-US" sz="5400" b="1" dirty="0">
+              <a:rPr lang="en-US" sz="3600" b="1" dirty="0">
+                <a:solidFill>
+                  <a:srgbClr val="0F4C5C"/>
+                </a:solidFill>
+              </a:rPr>
+              <a:t>Quando un ciclo si ferma</a:t>
+            </a:r>
+            <a:endParaRPr lang="en-US" sz="3600" dirty="0"/>
+          </a:p>
+        </p:txBody>
+      </p:sp>
+      <p:sp>
+        <p:nvSpPr>
+          <p:cNvPr id="3" name="Shape 1"/>
+          <p:cNvSpPr/>
+          <p:nvPr/>
+        </p:nvSpPr>
+        <p:spPr>
+          <a:xfrm>
+            <a:off x="548640" y="1737360"/>
+            <a:ext cx="5394960" cy="2743200"/>
+          </a:xfrm>
+          <a:prstGeom prst="roundRect">
+            <a:avLst>
+              <a:gd name="adj" fmla="val 4000"/>
+            </a:avLst>
+          </a:prstGeom>
+          <a:solidFill>
+            <a:srgbClr val="EEF3F4"/>
+          </a:solidFill>
+          <a:ln/>
+        </p:spPr>
+      </p:sp>
+      <p:sp>
+        <p:nvSpPr>
+          <p:cNvPr id="4" name="Text 2"/>
+          <p:cNvSpPr txBox="1"/>
+          <p:nvPr/>
+        </p:nvSpPr>
+        <p:spPr>
+          <a:xfrm>
+            <a:off x="822960" y="1965960"/>
+            <a:ext cx="4846320" cy="365760"/>
+          </a:xfrm>
+          <a:prstGeom prst="rect">
+            <a:avLst/>
+          </a:prstGeom>
+          <a:noFill/>
+          <a:ln/>
+        </p:spPr>
+        <p:txBody>
+          <a:bodyPr wrap="square" lIns="0" tIns="0" rIns="0" bIns="0" rtlCol="0" anchor="ctr"/>
+          <a:lstStyle/>
+          <a:p>
+            <a:pPr indent="0" marL="0">
+              <a:buNone/>
+            </a:pPr>
+            <a:r>
+              <a:rPr lang="en-US" sz="1300" b="1" spc="200" kern="0" dirty="0">
+                <a:solidFill>
+                  <a:srgbClr val="8F5308"/>
+                </a:solidFill>
+              </a:rPr>
+              <a:t>IL TRUCCO</a:t>
+            </a:r>
+            <a:endParaRPr lang="en-US" sz="1300" dirty="0"/>
+          </a:p>
+        </p:txBody>
+      </p:sp>
+      <p:sp>
+        <p:nvSpPr>
+          <p:cNvPr id="5" name="Text 3"/>
+          <p:cNvSpPr txBox="1"/>
+          <p:nvPr/>
+        </p:nvSpPr>
+        <p:spPr>
+          <a:xfrm>
+            <a:off x="822960" y="2423160"/>
+            <a:ext cx="4846320" cy="1874520"/>
+          </a:xfrm>
+          <a:prstGeom prst="rect">
+            <a:avLst/>
+          </a:prstGeom>
+          <a:noFill/>
+          <a:ln/>
+        </p:spPr>
+        <p:txBody>
+          <a:bodyPr wrap="square" lIns="0" tIns="0" rIns="0" bIns="0" rtlCol="0" anchor="t"/>
+          <a:lstStyle/>
+          <a:p>
+            <a:pPr indent="0" marL="0">
+              <a:buNone/>
+            </a:pPr>
+            <a:r>
+              <a:rPr lang="en-US" sz="1900" dirty="0">
+                <a:solidFill>
+                  <a:srgbClr val="1F2A30"/>
+                </a:solidFill>
+              </a:rPr>
+              <a:t>Stampa il nome del file prima di elaborarlo. Se si ferma con un errore, l'ultimo nome stampato è il colpevole.</a:t>
+            </a:r>
+            <a:endParaRPr lang="en-US" sz="1900" dirty="0"/>
+          </a:p>
+        </p:txBody>
+      </p:sp>
+      <p:sp>
+        <p:nvSpPr>
+          <p:cNvPr id="6" name="Shape 4"/>
+          <p:cNvSpPr/>
+          <p:nvPr/>
+        </p:nvSpPr>
+        <p:spPr>
+          <a:xfrm>
+            <a:off x="6217920" y="1737360"/>
+            <a:ext cx="5394960" cy="2743200"/>
+          </a:xfrm>
+          <a:prstGeom prst="roundRect">
+            <a:avLst>
+              <a:gd name="adj" fmla="val 4000"/>
+            </a:avLst>
+          </a:prstGeom>
+          <a:solidFill>
+            <a:srgbClr val="0F4C5C"/>
+          </a:solidFill>
+          <a:ln/>
+        </p:spPr>
+      </p:sp>
+      <p:sp>
+        <p:nvSpPr>
+          <p:cNvPr id="7" name="Text 5"/>
+          <p:cNvSpPr txBox="1"/>
+          <p:nvPr/>
+        </p:nvSpPr>
+        <p:spPr>
+          <a:xfrm>
+            <a:off x="6492240" y="1965960"/>
+            <a:ext cx="4846320" cy="365760"/>
+          </a:xfrm>
+          <a:prstGeom prst="rect">
+            <a:avLst/>
+          </a:prstGeom>
+          <a:noFill/>
+          <a:ln/>
+        </p:spPr>
+        <p:txBody>
+          <a:bodyPr wrap="square" lIns="0" tIns="0" rIns="0" bIns="0" rtlCol="0" anchor="ctr"/>
+          <a:lstStyle/>
+          <a:p>
+            <a:pPr indent="0" marL="0">
+              <a:buNone/>
+            </a:pPr>
+            <a:r>
+              <a:rPr lang="en-US" sz="1300" b="1" spc="200" kern="0" dirty="0">
+                <a:solidFill>
+                  <a:srgbClr val="F4C06E"/>
+                </a:solidFill>
+              </a:rPr>
+              <a:t>POI</a:t>
+            </a:r>
+            <a:endParaRPr lang="en-US" sz="1300" dirty="0"/>
+          </a:p>
+        </p:txBody>
+      </p:sp>
+      <p:sp>
+        <p:nvSpPr>
+          <p:cNvPr id="8" name="Text 6"/>
+          <p:cNvSpPr txBox="1"/>
+          <p:nvPr/>
+        </p:nvSpPr>
+        <p:spPr>
+          <a:xfrm>
+            <a:off x="6492240" y="2423160"/>
+            <a:ext cx="4846320" cy="1874520"/>
+          </a:xfrm>
+          <a:prstGeom prst="rect">
+            <a:avLst/>
+          </a:prstGeom>
+          <a:noFill/>
+          <a:ln/>
+        </p:spPr>
+        <p:txBody>
+          <a:bodyPr wrap="square" lIns="0" tIns="0" rIns="0" bIns="0" rtlCol="0" anchor="t"/>
+          <a:lstStyle/>
+          <a:p>
+            <a:pPr indent="0" marL="0">
+              <a:buNone/>
+            </a:pPr>
+            <a:r>
+              <a:rPr lang="en-US" sz="1900" dirty="0">
                 <a:solidFill>
                   <a:srgbClr val="FFFFFF"/>
                 </a:solidFill>
               </a:rPr>
-              <a:t>Task: 20 file, un riepilogo</a:t>
-            </a:r>
-            <a:endParaRPr lang="en-US" sz="5400" dirty="0"/>
-          </a:p>
-        </p:txBody>
-      </p:sp>
-      <p:sp>
-        <p:nvSpPr>
-          <p:cNvPr id="3" name="Text 0"/>
-          <p:cNvSpPr/>
-          <p:nvPr>
-            <p:ph idx="101" type="body" hasCustomPrompt="1"/>
-          </p:nvPr>
-        </p:nvSpPr>
-        <p:spPr>
-          <a:xfrm>
-            <a:off x="731520" y="3657600"/>
-            <a:ext cx="10698480" cy="1463040"/>
-          </a:xfrm>
-          <a:prstGeom prst="rect">
-            <a:avLst/>
-          </a:prstGeom>
-          <a:noFill/>
-          <a:ln/>
-        </p:spPr>
-        <p:txBody>
-          <a:bodyPr wrap="square" lIns="0" tIns="0" rIns="0" bIns="0" rtlCol="0" anchor="t"/>
-          <a:lstStyle/>
-          <a:p>
-            <a:pPr indent="0" marL="0">
-              <a:buNone/>
-            </a:pPr>
-            <a:r>
-              <a:rPr lang="en-US" sz="2200" dirty="0">
-                <a:solidFill>
-                  <a:srgbClr val="B8C4CB"/>
-                </a:solidFill>
-              </a:rPr>
-              <a:t>Scrivi la ricetta una volta, ripetila su tutti.</a:t>
-            </a:r>
-            <a:endParaRPr lang="en-US" sz="2200" dirty="0"/>
-          </a:p>
-          <a:p>
-            <a:pPr indent="0" marL="0">
-              <a:buNone/>
-            </a:pPr>
-            <a:r>
-              <a:rPr lang="en-US" sz="2200" dirty="0">
-                <a:solidFill>
-                  <a:srgbClr val="B8C4CB"/>
-                </a:solidFill>
-              </a:rPr>
-              <a:t>60 minuti · apri il notebook dal README</a:t>
-            </a:r>
-            <a:endParaRPr lang="en-US" sz="2200" dirty="0"/>
+              <a:t>Apri quel file e guardalo: cosa ha di diverso dagli altri? Correggi la funzione in modo che regga anche quel caso.</a:t>
+            </a:r>
+            <a:endParaRPr lang="en-US" sz="1900" dirty="0"/>
+          </a:p>
+        </p:txBody>
+      </p:sp>
+      <p:sp>
+        <p:nvSpPr>
+          <p:cNvPr id="9" name="Text 7"/>
+          <p:cNvSpPr txBox="1"/>
+          <p:nvPr/>
+        </p:nvSpPr>
+        <p:spPr>
+          <a:xfrm>
+            <a:off x="548640" y="4846320"/>
+            <a:ext cx="11064240" cy="457200"/>
+          </a:xfrm>
+          <a:prstGeom prst="rect">
+            <a:avLst/>
+          </a:prstGeom>
+          <a:noFill/>
+          <a:ln/>
+        </p:spPr>
+        <p:txBody>
+          <a:bodyPr wrap="square" lIns="0" tIns="0" rIns="0" bIns="0" rtlCol="0" anchor="ctr"/>
+          <a:lstStyle/>
+          <a:p>
+            <a:pPr indent="0" marL="0">
+              <a:buNone/>
+            </a:pPr>
+            <a:r>
+              <a:rPr lang="en-US" sz="1800" i="1" dirty="0">
+                <a:solidFill>
+                  <a:srgbClr val="0F4C5C"/>
+                </a:solidFill>
+              </a:rPr>
+              <a:t>I file «tutti uguali» non sono mai tutti uguali.</a:t>
+            </a:r>
+            <a:endParaRPr lang="en-US" sz="1800" dirty="0"/>
+          </a:p>
+        </p:txBody>
+      </p:sp>
+      <p:sp>
+        <p:nvSpPr>
+          <p:cNvPr id="25" name="Slide Number Placeholder 0"/>
+          <p:cNvSpPr>
+            <a:spLocks noGrp="1"/>
+          </p:cNvSpPr>
+          <p:nvPr>
+            <p:ph type="sldNum" sz="quarter" idx="4294967295"/>
+          </p:nvPr>
+        </p:nvSpPr>
+        <p:spPr>
+          <a:xfrm>
+            <a:off x="11155680" y="6400800"/>
+            <a:ext cx="457200" cy="274320"/>
+          </a:xfrm>
+          <a:prstGeom prst="rect">
+            <a:avLst/>
+          </a:prstGeom>
+          <a:extLst>
+            <a:ext uri="{C572A759-6A51-4108-AA02-DFA0A04FC94B}">
+              <ma14:wrappingTextBoxFlag xmlns:ma14="http://schemas.microsoft.com/office/mac/drawingml/2011/main" val="0"/>
+            </a:ext>
+          </a:extLst>
+        </p:spPr>
+        <p:txBody>
+          <a:bodyPr/>
+          <a:lstStyle>
+            <a:lvl1pPr>
+              <a:defRPr sz="1000">
+                <a:solidFill>
+                  <a:srgbClr val="5C6F7B"/>
+                </a:solidFill>
+              </a:defRPr>
+            </a:lvl1pPr>
+          </a:lstStyle>
+          <a:p>
+            <a:pPr algn="r"/>
+            <a:fld id="{F7021451-1387-4CA6-816F-3879F97B5CBC}" type="slidenum">
+              <a:rPr b="0" lang="en-US"/>
+              <a:t>8</a:t>
+            </a:fld>
+            <a:endParaRPr lang="en-US"/>
           </a:p>
         </p:txBody>
       </p:sp>
@@ -6395,7 +6856,7 @@
                   <a:srgbClr val="FFFFFF"/>
                 </a:solidFill>
               </a:rPr>
-              <a:t>Debrief</a:t>
+              <a:t>Task: 20 file, un riepilogo</a:t>
             </a:r>
             <a:endParaRPr lang="en-US" sz="5400" dirty="0"/>
           </a:p>
@@ -6433,7 +6894,21 @@
                   <a:srgbClr val="B8C4CB"/>
                 </a:solidFill>
               </a:rPr>
-              <a:t>Il file diverso dagli altri</a:t>
+              <a:t>Scrivi la ricetta una volta, ripetila su tutti.</a:t>
+            </a:r>
+            <a:endParaRPr lang="en-US" sz="2200" dirty="0"/>
+          </a:p>
+          <a:p>
+            <a:pPr indent="0" marL="0">
+              <a:buNone/>
+            </a:pPr>
+            <a:r>
+              <a:rPr lang="en-US" sz="2200" dirty="0">
+                <a:solidFill>
+                  <a:srgbClr val="B8C4CB"/>
+                </a:solidFill>
+              </a:rPr>
+              <a:t>60 minuti · apri il notebook dal README</a:t>
             </a:r>
             <a:endParaRPr lang="en-US" sz="2200" dirty="0"/>
           </a:p>

</xml_diff>